<commit_message>
merged ppt  in presentation file
</commit_message>
<xml_diff>
--- a/ICT710_AT3_GroupPPT (1).pptx
+++ b/ICT710_AT3_GroupPPT (1).pptx
@@ -5,19 +5,19 @@
     <p:sldMasterId id="2147483648" r:id="rId1"/>
   </p:sldMasterIdLst>
   <p:sldIdLst>
-    <p:sldId id="256" r:id="rId3"/>
-    <p:sldId id="259" r:id="rId4"/>
-    <p:sldId id="261" r:id="rId5"/>
-    <p:sldId id="260" r:id="rId6"/>
-    <p:sldId id="263" r:id="rId7"/>
-    <p:sldId id="262" r:id="rId8"/>
-    <p:sldId id="265" r:id="rId9"/>
-    <p:sldId id="264" r:id="rId10"/>
-    <p:sldId id="266" r:id="rId11"/>
-    <p:sldId id="268" r:id="rId12"/>
-    <p:sldId id="269" r:id="rId13"/>
-    <p:sldId id="267" r:id="rId14"/>
-    <p:sldId id="270" r:id="rId15"/>
+    <p:sldId id="256" r:id="rId2"/>
+    <p:sldId id="259" r:id="rId3"/>
+    <p:sldId id="261" r:id="rId4"/>
+    <p:sldId id="260" r:id="rId5"/>
+    <p:sldId id="263" r:id="rId6"/>
+    <p:sldId id="262" r:id="rId7"/>
+    <p:sldId id="265" r:id="rId8"/>
+    <p:sldId id="264" r:id="rId9"/>
+    <p:sldId id="266" r:id="rId10"/>
+    <p:sldId id="268" r:id="rId11"/>
+    <p:sldId id="269" r:id="rId12"/>
+    <p:sldId id="267" r:id="rId13"/>
+    <p:sldId id="270" r:id="rId14"/>
   </p:sldIdLst>
   <p:sldSz cx="12192000" cy="6858000"/>
   <p:notesSz cx="6858000" cy="9144000"/>
@@ -266,6 +266,7 @@
           <a:p>
             <a:fld id="{63A1C593-65D0-4073-BCC9-577B9352EA97}" type="datetimeFigureOut">
               <a:rPr lang="en-US" smtClean="0"/>
+              <a:t>5/27/2026</a:t>
             </a:fld>
             <a:endParaRPr lang="en-US"/>
           </a:p>
@@ -307,6 +308,7 @@
           <a:p>
             <a:fld id="{9B618960-8005-486C-9A75-10CB2AAC16F9}" type="slidenum">
               <a:rPr lang="en-US" smtClean="0"/>
+              <a:t>‹#›</a:t>
             </a:fld>
             <a:endParaRPr lang="en-US"/>
           </a:p>
@@ -380,7 +382,6 @@
               <a:rPr lang="en-US" smtClean="0"/>
               <a:t>Click to edit Master text styles</a:t>
             </a:r>
-            <a:endParaRPr lang="en-US" smtClean="0"/>
           </a:p>
           <a:p>
             <a:pPr lvl="1"/>
@@ -388,7 +389,6 @@
               <a:rPr lang="en-US" smtClean="0"/>
               <a:t>Second level</a:t>
             </a:r>
-            <a:endParaRPr lang="en-US" smtClean="0"/>
           </a:p>
           <a:p>
             <a:pPr lvl="2"/>
@@ -396,7 +396,6 @@
               <a:rPr lang="en-US" smtClean="0"/>
               <a:t>Third level</a:t>
             </a:r>
-            <a:endParaRPr lang="en-US" smtClean="0"/>
           </a:p>
           <a:p>
             <a:pPr lvl="3"/>
@@ -404,7 +403,6 @@
               <a:rPr lang="en-US" smtClean="0"/>
               <a:t>Fourth level</a:t>
             </a:r>
-            <a:endParaRPr lang="en-US" smtClean="0"/>
           </a:p>
           <a:p>
             <a:pPr lvl="4"/>
@@ -433,6 +431,7 @@
           <a:p>
             <a:fld id="{63A1C593-65D0-4073-BCC9-577B9352EA97}" type="datetimeFigureOut">
               <a:rPr lang="en-US" smtClean="0"/>
+              <a:t>5/27/2026</a:t>
             </a:fld>
             <a:endParaRPr lang="en-US"/>
           </a:p>
@@ -474,6 +473,7 @@
           <a:p>
             <a:fld id="{9B618960-8005-486C-9A75-10CB2AAC16F9}" type="slidenum">
               <a:rPr lang="en-US" smtClean="0"/>
+              <a:t>‹#›</a:t>
             </a:fld>
             <a:endParaRPr lang="en-US"/>
           </a:p>
@@ -557,7 +557,6 @@
               <a:rPr lang="en-US" smtClean="0"/>
               <a:t>Click to edit Master text styles</a:t>
             </a:r>
-            <a:endParaRPr lang="en-US" smtClean="0"/>
           </a:p>
           <a:p>
             <a:pPr lvl="1"/>
@@ -565,7 +564,6 @@
               <a:rPr lang="en-US" smtClean="0"/>
               <a:t>Second level</a:t>
             </a:r>
-            <a:endParaRPr lang="en-US" smtClean="0"/>
           </a:p>
           <a:p>
             <a:pPr lvl="2"/>
@@ -573,7 +571,6 @@
               <a:rPr lang="en-US" smtClean="0"/>
               <a:t>Third level</a:t>
             </a:r>
-            <a:endParaRPr lang="en-US" smtClean="0"/>
           </a:p>
           <a:p>
             <a:pPr lvl="3"/>
@@ -581,7 +578,6 @@
               <a:rPr lang="en-US" smtClean="0"/>
               <a:t>Fourth level</a:t>
             </a:r>
-            <a:endParaRPr lang="en-US" smtClean="0"/>
           </a:p>
           <a:p>
             <a:pPr lvl="4"/>
@@ -610,6 +606,7 @@
           <a:p>
             <a:fld id="{63A1C593-65D0-4073-BCC9-577B9352EA97}" type="datetimeFigureOut">
               <a:rPr lang="en-US" smtClean="0"/>
+              <a:t>5/27/2026</a:t>
             </a:fld>
             <a:endParaRPr lang="en-US"/>
           </a:p>
@@ -651,6 +648,7 @@
           <a:p>
             <a:fld id="{9B618960-8005-486C-9A75-10CB2AAC16F9}" type="slidenum">
               <a:rPr lang="en-US" smtClean="0"/>
+              <a:t>‹#›</a:t>
             </a:fld>
             <a:endParaRPr lang="en-US"/>
           </a:p>
@@ -724,7 +722,6 @@
               <a:rPr lang="en-US" smtClean="0"/>
               <a:t>Click to edit Master text styles</a:t>
             </a:r>
-            <a:endParaRPr lang="en-US" smtClean="0"/>
           </a:p>
           <a:p>
             <a:pPr lvl="1"/>
@@ -732,7 +729,6 @@
               <a:rPr lang="en-US" smtClean="0"/>
               <a:t>Second level</a:t>
             </a:r>
-            <a:endParaRPr lang="en-US" smtClean="0"/>
           </a:p>
           <a:p>
             <a:pPr lvl="2"/>
@@ -740,7 +736,6 @@
               <a:rPr lang="en-US" smtClean="0"/>
               <a:t>Third level</a:t>
             </a:r>
-            <a:endParaRPr lang="en-US" smtClean="0"/>
           </a:p>
           <a:p>
             <a:pPr lvl="3"/>
@@ -748,7 +743,6 @@
               <a:rPr lang="en-US" smtClean="0"/>
               <a:t>Fourth level</a:t>
             </a:r>
-            <a:endParaRPr lang="en-US" smtClean="0"/>
           </a:p>
           <a:p>
             <a:pPr lvl="4"/>
@@ -777,6 +771,7 @@
           <a:p>
             <a:fld id="{63A1C593-65D0-4073-BCC9-577B9352EA97}" type="datetimeFigureOut">
               <a:rPr lang="en-US" smtClean="0"/>
+              <a:t>5/27/2026</a:t>
             </a:fld>
             <a:endParaRPr lang="en-US"/>
           </a:p>
@@ -818,6 +813,7 @@
           <a:p>
             <a:fld id="{9B618960-8005-486C-9A75-10CB2AAC16F9}" type="slidenum">
               <a:rPr lang="en-US" smtClean="0"/>
+              <a:t>‹#›</a:t>
             </a:fld>
             <a:endParaRPr lang="en-US"/>
           </a:p>
@@ -996,7 +992,6 @@
               <a:rPr lang="en-US" smtClean="0"/>
               <a:t>Click to edit Master text styles</a:t>
             </a:r>
-            <a:endParaRPr lang="en-US" smtClean="0"/>
           </a:p>
         </p:txBody>
       </p:sp>
@@ -1017,6 +1012,7 @@
           <a:p>
             <a:fld id="{63A1C593-65D0-4073-BCC9-577B9352EA97}" type="datetimeFigureOut">
               <a:rPr lang="en-US" smtClean="0"/>
+              <a:t>5/27/2026</a:t>
             </a:fld>
             <a:endParaRPr lang="en-US"/>
           </a:p>
@@ -1058,6 +1054,7 @@
           <a:p>
             <a:fld id="{9B618960-8005-486C-9A75-10CB2AAC16F9}" type="slidenum">
               <a:rPr lang="en-US" smtClean="0"/>
+              <a:t>‹#›</a:t>
             </a:fld>
             <a:endParaRPr lang="en-US"/>
           </a:p>
@@ -1136,7 +1133,6 @@
               <a:rPr lang="en-US" smtClean="0"/>
               <a:t>Click to edit Master text styles</a:t>
             </a:r>
-            <a:endParaRPr lang="en-US" smtClean="0"/>
           </a:p>
           <a:p>
             <a:pPr lvl="1"/>
@@ -1144,7 +1140,6 @@
               <a:rPr lang="en-US" smtClean="0"/>
               <a:t>Second level</a:t>
             </a:r>
-            <a:endParaRPr lang="en-US" smtClean="0"/>
           </a:p>
           <a:p>
             <a:pPr lvl="2"/>
@@ -1152,7 +1147,6 @@
               <a:rPr lang="en-US" smtClean="0"/>
               <a:t>Third level</a:t>
             </a:r>
-            <a:endParaRPr lang="en-US" smtClean="0"/>
           </a:p>
           <a:p>
             <a:pPr lvl="3"/>
@@ -1160,7 +1154,6 @@
               <a:rPr lang="en-US" smtClean="0"/>
               <a:t>Fourth level</a:t>
             </a:r>
-            <a:endParaRPr lang="en-US" smtClean="0"/>
           </a:p>
           <a:p>
             <a:pPr lvl="4"/>
@@ -1197,7 +1190,6 @@
               <a:rPr lang="en-US" smtClean="0"/>
               <a:t>Click to edit Master text styles</a:t>
             </a:r>
-            <a:endParaRPr lang="en-US" smtClean="0"/>
           </a:p>
           <a:p>
             <a:pPr lvl="1"/>
@@ -1205,7 +1197,6 @@
               <a:rPr lang="en-US" smtClean="0"/>
               <a:t>Second level</a:t>
             </a:r>
-            <a:endParaRPr lang="en-US" smtClean="0"/>
           </a:p>
           <a:p>
             <a:pPr lvl="2"/>
@@ -1213,7 +1204,6 @@
               <a:rPr lang="en-US" smtClean="0"/>
               <a:t>Third level</a:t>
             </a:r>
-            <a:endParaRPr lang="en-US" smtClean="0"/>
           </a:p>
           <a:p>
             <a:pPr lvl="3"/>
@@ -1221,7 +1211,6 @@
               <a:rPr lang="en-US" smtClean="0"/>
               <a:t>Fourth level</a:t>
             </a:r>
-            <a:endParaRPr lang="en-US" smtClean="0"/>
           </a:p>
           <a:p>
             <a:pPr lvl="4"/>
@@ -1250,6 +1239,7 @@
           <a:p>
             <a:fld id="{63A1C593-65D0-4073-BCC9-577B9352EA97}" type="datetimeFigureOut">
               <a:rPr lang="en-US" smtClean="0"/>
+              <a:t>5/27/2026</a:t>
             </a:fld>
             <a:endParaRPr lang="en-US"/>
           </a:p>
@@ -1291,6 +1281,7 @@
           <a:p>
             <a:fld id="{9B618960-8005-486C-9A75-10CB2AAC16F9}" type="slidenum">
               <a:rPr lang="en-US" smtClean="0"/>
+              <a:t>‹#›</a:t>
             </a:fld>
             <a:endParaRPr lang="en-US"/>
           </a:p>
@@ -1411,7 +1402,6 @@
               <a:rPr lang="en-US" smtClean="0"/>
               <a:t>Click to edit Master text styles</a:t>
             </a:r>
-            <a:endParaRPr lang="en-US" smtClean="0"/>
           </a:p>
         </p:txBody>
       </p:sp>
@@ -1440,7 +1430,6 @@
               <a:rPr lang="en-US" smtClean="0"/>
               <a:t>Click to edit Master text styles</a:t>
             </a:r>
-            <a:endParaRPr lang="en-US" smtClean="0"/>
           </a:p>
           <a:p>
             <a:pPr lvl="1"/>
@@ -1448,7 +1437,6 @@
               <a:rPr lang="en-US" smtClean="0"/>
               <a:t>Second level</a:t>
             </a:r>
-            <a:endParaRPr lang="en-US" smtClean="0"/>
           </a:p>
           <a:p>
             <a:pPr lvl="2"/>
@@ -1456,7 +1444,6 @@
               <a:rPr lang="en-US" smtClean="0"/>
               <a:t>Third level</a:t>
             </a:r>
-            <a:endParaRPr lang="en-US" smtClean="0"/>
           </a:p>
           <a:p>
             <a:pPr lvl="3"/>
@@ -1464,7 +1451,6 @@
               <a:rPr lang="en-US" smtClean="0"/>
               <a:t>Fourth level</a:t>
             </a:r>
-            <a:endParaRPr lang="en-US" smtClean="0"/>
           </a:p>
           <a:p>
             <a:pPr lvl="4"/>
@@ -1538,7 +1524,6 @@
               <a:rPr lang="en-US" smtClean="0"/>
               <a:t>Click to edit Master text styles</a:t>
             </a:r>
-            <a:endParaRPr lang="en-US" smtClean="0"/>
           </a:p>
         </p:txBody>
       </p:sp>
@@ -1567,7 +1552,6 @@
               <a:rPr lang="en-US" smtClean="0"/>
               <a:t>Click to edit Master text styles</a:t>
             </a:r>
-            <a:endParaRPr lang="en-US" smtClean="0"/>
           </a:p>
           <a:p>
             <a:pPr lvl="1"/>
@@ -1575,7 +1559,6 @@
               <a:rPr lang="en-US" smtClean="0"/>
               <a:t>Second level</a:t>
             </a:r>
-            <a:endParaRPr lang="en-US" smtClean="0"/>
           </a:p>
           <a:p>
             <a:pPr lvl="2"/>
@@ -1583,7 +1566,6 @@
               <a:rPr lang="en-US" smtClean="0"/>
               <a:t>Third level</a:t>
             </a:r>
-            <a:endParaRPr lang="en-US" smtClean="0"/>
           </a:p>
           <a:p>
             <a:pPr lvl="3"/>
@@ -1591,7 +1573,6 @@
               <a:rPr lang="en-US" smtClean="0"/>
               <a:t>Fourth level</a:t>
             </a:r>
-            <a:endParaRPr lang="en-US" smtClean="0"/>
           </a:p>
           <a:p>
             <a:pPr lvl="4"/>
@@ -1620,6 +1601,7 @@
           <a:p>
             <a:fld id="{63A1C593-65D0-4073-BCC9-577B9352EA97}" type="datetimeFigureOut">
               <a:rPr lang="en-US" smtClean="0"/>
+              <a:t>5/27/2026</a:t>
             </a:fld>
             <a:endParaRPr lang="en-US"/>
           </a:p>
@@ -1661,6 +1643,7 @@
           <a:p>
             <a:fld id="{9B618960-8005-486C-9A75-10CB2AAC16F9}" type="slidenum">
               <a:rPr lang="en-US" smtClean="0"/>
+              <a:t>‹#›</a:t>
             </a:fld>
             <a:endParaRPr lang="en-US"/>
           </a:p>
@@ -1731,6 +1714,7 @@
           <a:p>
             <a:fld id="{63A1C593-65D0-4073-BCC9-577B9352EA97}" type="datetimeFigureOut">
               <a:rPr lang="en-US" smtClean="0"/>
+              <a:t>5/27/2026</a:t>
             </a:fld>
             <a:endParaRPr lang="en-US"/>
           </a:p>
@@ -1772,6 +1756,7 @@
           <a:p>
             <a:fld id="{9B618960-8005-486C-9A75-10CB2AAC16F9}" type="slidenum">
               <a:rPr lang="en-US" smtClean="0"/>
+              <a:t>‹#›</a:t>
             </a:fld>
             <a:endParaRPr lang="en-US"/>
           </a:p>
@@ -1819,6 +1804,7 @@
           <a:p>
             <a:fld id="{63A1C593-65D0-4073-BCC9-577B9352EA97}" type="datetimeFigureOut">
               <a:rPr lang="en-US" smtClean="0"/>
+              <a:t>5/27/2026</a:t>
             </a:fld>
             <a:endParaRPr lang="en-US"/>
           </a:p>
@@ -1860,6 +1846,7 @@
           <a:p>
             <a:fld id="{9B618960-8005-486C-9A75-10CB2AAC16F9}" type="slidenum">
               <a:rPr lang="en-US" smtClean="0"/>
+              <a:t>‹#›</a:t>
             </a:fld>
             <a:endParaRPr lang="en-US"/>
           </a:p>
@@ -1975,7 +1962,6 @@
               <a:rPr lang="en-US" smtClean="0"/>
               <a:t>Click to edit Master text styles</a:t>
             </a:r>
-            <a:endParaRPr lang="en-US" smtClean="0"/>
           </a:p>
           <a:p>
             <a:pPr lvl="1"/>
@@ -1983,7 +1969,6 @@
               <a:rPr lang="en-US" smtClean="0"/>
               <a:t>Second level</a:t>
             </a:r>
-            <a:endParaRPr lang="en-US" smtClean="0"/>
           </a:p>
           <a:p>
             <a:pPr lvl="2"/>
@@ -1991,7 +1976,6 @@
               <a:rPr lang="en-US" smtClean="0"/>
               <a:t>Third level</a:t>
             </a:r>
-            <a:endParaRPr lang="en-US" smtClean="0"/>
           </a:p>
           <a:p>
             <a:pPr lvl="3"/>
@@ -1999,7 +1983,6 @@
               <a:rPr lang="en-US" smtClean="0"/>
               <a:t>Fourth level</a:t>
             </a:r>
-            <a:endParaRPr lang="en-US" smtClean="0"/>
           </a:p>
           <a:p>
             <a:pPr lvl="4"/>
@@ -2073,7 +2056,6 @@
               <a:rPr lang="en-US" smtClean="0"/>
               <a:t>Click to edit Master text styles</a:t>
             </a:r>
-            <a:endParaRPr lang="en-US" smtClean="0"/>
           </a:p>
         </p:txBody>
       </p:sp>
@@ -2094,6 +2076,7 @@
           <a:p>
             <a:fld id="{63A1C593-65D0-4073-BCC9-577B9352EA97}" type="datetimeFigureOut">
               <a:rPr lang="en-US" smtClean="0"/>
+              <a:t>5/27/2026</a:t>
             </a:fld>
             <a:endParaRPr lang="en-US"/>
           </a:p>
@@ -2135,6 +2118,7 @@
           <a:p>
             <a:fld id="{9B618960-8005-486C-9A75-10CB2AAC16F9}" type="slidenum">
               <a:rPr lang="en-US" smtClean="0"/>
+              <a:t>‹#›</a:t>
             </a:fld>
             <a:endParaRPr lang="en-US"/>
           </a:p>
@@ -2320,7 +2304,6 @@
               <a:rPr lang="en-US" smtClean="0"/>
               <a:t>Click to edit Master text styles</a:t>
             </a:r>
-            <a:endParaRPr lang="en-US" smtClean="0"/>
           </a:p>
         </p:txBody>
       </p:sp>
@@ -2341,6 +2324,7 @@
           <a:p>
             <a:fld id="{63A1C593-65D0-4073-BCC9-577B9352EA97}" type="datetimeFigureOut">
               <a:rPr lang="en-US" smtClean="0"/>
+              <a:t>5/27/2026</a:t>
             </a:fld>
             <a:endParaRPr lang="en-US"/>
           </a:p>
@@ -2382,6 +2366,7 @@
           <a:p>
             <a:fld id="{9B618960-8005-486C-9A75-10CB2AAC16F9}" type="slidenum">
               <a:rPr lang="en-US" smtClean="0"/>
+              <a:t>‹#›</a:t>
             </a:fld>
             <a:endParaRPr lang="en-US"/>
           </a:p>
@@ -2480,7 +2465,6 @@
               <a:rPr lang="en-US" smtClean="0"/>
               <a:t>Click to edit Master text styles</a:t>
             </a:r>
-            <a:endParaRPr lang="en-US" smtClean="0"/>
           </a:p>
           <a:p>
             <a:pPr lvl="1"/>
@@ -2488,7 +2472,6 @@
               <a:rPr lang="en-US" smtClean="0"/>
               <a:t>Second level</a:t>
             </a:r>
-            <a:endParaRPr lang="en-US" smtClean="0"/>
           </a:p>
           <a:p>
             <a:pPr lvl="2"/>
@@ -2496,7 +2479,6 @@
               <a:rPr lang="en-US" smtClean="0"/>
               <a:t>Third level</a:t>
             </a:r>
-            <a:endParaRPr lang="en-US" smtClean="0"/>
           </a:p>
           <a:p>
             <a:pPr lvl="3"/>
@@ -2504,7 +2486,6 @@
               <a:rPr lang="en-US" smtClean="0"/>
               <a:t>Fourth level</a:t>
             </a:r>
-            <a:endParaRPr lang="en-US" smtClean="0"/>
           </a:p>
           <a:p>
             <a:pPr lvl="4"/>
@@ -2551,6 +2532,7 @@
           <a:p>
             <a:fld id="{63A1C593-65D0-4073-BCC9-577B9352EA97}" type="datetimeFigureOut">
               <a:rPr lang="en-US" smtClean="0"/>
+              <a:t>5/27/2026</a:t>
             </a:fld>
             <a:endParaRPr lang="en-US"/>
           </a:p>
@@ -2628,6 +2610,7 @@
           <a:p>
             <a:fld id="{9B618960-8005-486C-9A75-10CB2AAC16F9}" type="slidenum">
               <a:rPr lang="en-US" smtClean="0"/>
+              <a:t>‹#›</a:t>
             </a:fld>
             <a:endParaRPr lang="en-US"/>
           </a:p>
@@ -2985,12 +2968,13 @@
         </p:spPr>
         <p:txBody>
           <a:bodyPr/>
+          <a:lstStyle/>
           <a:p>
             <a:pPr marL="0" indent="0" algn="ctr">
               <a:buNone/>
             </a:pPr>
             <a:r>
-              <a:rPr lang="en-US" sz="4000" dirty="0">
+              <a:rPr lang="en-US" sz="4000" smtClean="0">
                 <a:solidFill>
                   <a:srgbClr val="00C4FF"/>
                 </a:solidFill>
@@ -2998,16 +2982,19 @@
                 <a:cs typeface="Times New Roman" panose="02020603050405020304" charset="0"/>
                 <a:sym typeface="+mn-ea"/>
               </a:rPr>
-              <a:t>ICT701- Interaction Design &amp; Usability</a:t>
-            </a:r>
-            <a:endParaRPr lang="en-US" sz="4000" dirty="0">
-              <a:solidFill>
-                <a:srgbClr val="00C4FF"/>
-              </a:solidFill>
-              <a:latin typeface="Times New Roman" panose="02020603050405020304" charset="0"/>
-              <a:cs typeface="Times New Roman" panose="02020603050405020304" charset="0"/>
-              <a:sym typeface="+mn-ea"/>
-            </a:endParaRPr>
+              <a:t>ICT710- </a:t>
+            </a:r>
+            <a:r>
+              <a:rPr lang="en-US" sz="4000" dirty="0">
+                <a:solidFill>
+                  <a:srgbClr val="00C4FF"/>
+                </a:solidFill>
+                <a:latin typeface="Times New Roman" panose="02020603050405020304" charset="0"/>
+                <a:cs typeface="Times New Roman" panose="02020603050405020304" charset="0"/>
+                <a:sym typeface="+mn-ea"/>
+              </a:rPr>
+              <a:t>Interaction Design &amp; Usability</a:t>
+            </a:r>
           </a:p>
           <a:p>
             <a:pPr marL="0" indent="0" algn="ctr">
@@ -3040,14 +3027,6 @@
               </a:rPr>
               <a:t>Assessment 3: Design Report</a:t>
             </a:r>
-            <a:endParaRPr lang="en-US" altLang="en-US" sz="3200" b="1" dirty="0">
-              <a:solidFill>
-                <a:srgbClr val="FFFFFF"/>
-              </a:solidFill>
-              <a:latin typeface="Times New Roman" panose="02020603050405020304" charset="0"/>
-              <a:cs typeface="Times New Roman" panose="02020603050405020304" charset="0"/>
-              <a:sym typeface="+mn-ea"/>
-            </a:endParaRPr>
           </a:p>
           <a:p>
             <a:pPr marL="0" indent="0" algn="ctr">
@@ -3067,20 +3046,12 @@
               </a:rPr>
               <a:t>Trading Mobile Application</a:t>
             </a:r>
-            <a:endParaRPr lang="en-US" sz="3200" b="1" dirty="0">
-              <a:solidFill>
-                <a:srgbClr val="FFFFFF"/>
-              </a:solidFill>
-              <a:latin typeface="Times New Roman" panose="02020603050405020304" charset="0"/>
-              <a:cs typeface="Times New Roman" panose="02020603050405020304" charset="0"/>
-              <a:sym typeface="+mn-ea"/>
-            </a:endParaRPr>
           </a:p>
           <a:p>
             <a:pPr marL="0" indent="0" algn="ctr">
               <a:buNone/>
             </a:pPr>
-            <a:endParaRPr lang="en-US" sz="4000">
+            <a:endParaRPr lang="en-US" sz="4000" dirty="0">
               <a:latin typeface="Times New Roman" panose="02020603050405020304" charset="0"/>
               <a:cs typeface="Times New Roman" panose="02020603050405020304" charset="0"/>
             </a:endParaRPr>
@@ -3089,7 +3060,7 @@
             <a:pPr marL="0" indent="0" algn="ctr">
               <a:buNone/>
             </a:pPr>
-            <a:endParaRPr lang="en-US" sz="4000">
+            <a:endParaRPr lang="en-US" sz="4000" dirty="0">
               <a:latin typeface="Times New Roman" panose="02020603050405020304" charset="0"/>
               <a:cs typeface="Times New Roman" panose="02020603050405020304" charset="0"/>
             </a:endParaRPr>
@@ -3098,7 +3069,7 @@
             <a:pPr marL="0" indent="0" algn="ctr">
               <a:buNone/>
             </a:pPr>
-            <a:endParaRPr lang="en-US" sz="4000">
+            <a:endParaRPr lang="en-US" sz="4000" dirty="0">
               <a:latin typeface="Times New Roman" panose="02020603050405020304" charset="0"/>
               <a:cs typeface="Times New Roman" panose="02020603050405020304" charset="0"/>
             </a:endParaRPr>
@@ -3140,6 +3111,7 @@
         </p:spPr>
         <p:txBody>
           <a:bodyPr/>
+          <a:lstStyle/>
           <a:p>
             <a:pPr marL="0" indent="0" algn="ctr">
               <a:buNone/>
@@ -3294,13 +3266,26 @@
             <a:tbl>
               <a:tblPr/>
               <a:tblGrid>
-                <a:gridCol w="3180080"/>
-                <a:gridCol w="3098800"/>
+                <a:gridCol w="3180080">
+                  <a:extLst>
+                    <a:ext uri="{9D8B030D-6E8A-4147-A177-3AD203B41FA5}">
+                      <a16:colId xmlns:a16="http://schemas.microsoft.com/office/drawing/2014/main" val="20000"/>
+                    </a:ext>
+                  </a:extLst>
+                </a:gridCol>
+                <a:gridCol w="3098800">
+                  <a:extLst>
+                    <a:ext uri="{9D8B030D-6E8A-4147-A177-3AD203B41FA5}">
+                      <a16:colId xmlns:a16="http://schemas.microsoft.com/office/drawing/2014/main" val="20001"/>
+                    </a:ext>
+                  </a:extLst>
+                </a:gridCol>
               </a:tblGrid>
               <a:tr h="459740">
                 <a:tc>
                   <a:txBody>
                     <a:bodyPr/>
+                    <a:lstStyle/>
                     <a:p>
                       <a:pPr marL="0" indent="0" algn="ctr">
                         <a:lnSpc>
@@ -3318,29 +3303,11 @@
                           <a:latin typeface="Times New Roman" panose="02020603050405020304"/>
                           <a:ea typeface="Times New Roman" panose="02020603050405020304"/>
                         </a:rPr>
-                        <a:t>Shradhdha </a:t>
+                        <a:t>Shradhdha Neel Diyora</a:t>
                       </a:r>
-                      <a:r>
-                        <a:rPr sz="1600" b="1">
-                          <a:latin typeface="Times New Roman" panose="02020603050405020304"/>
-                          <a:ea typeface="Times New Roman" panose="02020603050405020304"/>
-                        </a:rPr>
-                        <a:t>Neel </a:t>
-                      </a:r>
-                      <a:r>
-                        <a:rPr sz="1600" b="1">
-                          <a:latin typeface="Times New Roman" panose="02020603050405020304"/>
-                          <a:ea typeface="Times New Roman" panose="02020603050405020304"/>
-                        </a:rPr>
-                        <a:t>Diyora</a:t>
-                      </a:r>
-                      <a:endParaRPr sz="1600" b="1">
-                        <a:latin typeface="Times New Roman" panose="02020603050405020304"/>
-                        <a:ea typeface="Times New Roman" panose="02020603050405020304"/>
-                      </a:endParaRPr>
                     </a:p>
                   </a:txBody>
-                  <a:tcPr marL="68580" marR="68580" marT="0" marB="0" anchor="t" anchorCtr="0">
+                  <a:tcPr marL="68580" marR="68580" marT="0" marB="0">
                     <a:lnL w="6350" cap="flat" cmpd="sng">
                       <a:solidFill>
                         <a:srgbClr val="000008"/>
@@ -3397,6 +3364,7 @@
                 <a:tc>
                   <a:txBody>
                     <a:bodyPr/>
+                    <a:lstStyle/>
                     <a:p>
                       <a:pPr marL="0" indent="0" algn="ctr">
                         <a:lnSpc>
@@ -3416,13 +3384,9 @@
                         </a:rPr>
                         <a:t>65430</a:t>
                       </a:r>
-                      <a:endParaRPr sz="1600" b="1">
-                        <a:latin typeface="Times New Roman" panose="02020603050405020304"/>
-                        <a:ea typeface="Times New Roman" panose="02020603050405020304"/>
-                      </a:endParaRPr>
                     </a:p>
                   </a:txBody>
-                  <a:tcPr marL="68580" marR="68580" marT="0" marB="0" anchor="t" anchorCtr="0">
+                  <a:tcPr marL="68580" marR="68580" marT="0" marB="0">
                     <a:lnL w="6350" cap="flat" cmpd="sng">
                       <a:solidFill>
                         <a:srgbClr val="000008"/>
@@ -3476,11 +3440,17 @@
                     </a:gradFill>
                   </a:tcPr>
                 </a:tc>
+                <a:extLst>
+                  <a:ext uri="{0D108BD9-81ED-4DB2-BD59-A6C34878D82A}">
+                    <a16:rowId xmlns:a16="http://schemas.microsoft.com/office/drawing/2014/main" val="10000"/>
+                  </a:ext>
+                </a:extLst>
               </a:tr>
               <a:tr h="459740">
                 <a:tc>
                   <a:txBody>
                     <a:bodyPr/>
+                    <a:lstStyle/>
                     <a:p>
                       <a:pPr marL="0" indent="0" algn="ctr">
                         <a:lnSpc>
@@ -3498,36 +3468,11 @@
                           <a:latin typeface="Times New Roman" panose="02020603050405020304"/>
                           <a:ea typeface="Times New Roman" panose="02020603050405020304"/>
                         </a:rPr>
-                        <a:t>H</a:t>
+                        <a:t>Hiren Kanubhai Italiya</a:t>
                       </a:r>
-                      <a:r>
-                        <a:rPr sz="1600" b="1">
-                          <a:latin typeface="Times New Roman" panose="02020603050405020304"/>
-                          <a:ea typeface="Times New Roman" panose="02020603050405020304"/>
-                        </a:rPr>
-                        <a:t>iren K</a:t>
-                      </a:r>
-                      <a:r>
-                        <a:rPr sz="1600" b="1">
-                          <a:latin typeface="Times New Roman" panose="02020603050405020304"/>
-                          <a:ea typeface="Times New Roman" panose="02020603050405020304"/>
-                        </a:rPr>
-                        <a:t>anubhai I</a:t>
-                      </a:r>
-                      <a:r>
-                        <a:rPr sz="1600" b="1">
-                          <a:latin typeface="Times New Roman" panose="02020603050405020304"/>
-                          <a:ea typeface="Times New Roman" panose="02020603050405020304"/>
-                        </a:rPr>
-                        <a:t>taliya</a:t>
-                      </a:r>
-                      <a:endParaRPr sz="1600" b="1">
-                        <a:latin typeface="Times New Roman" panose="02020603050405020304"/>
-                        <a:ea typeface="Times New Roman" panose="02020603050405020304"/>
-                      </a:endParaRPr>
                     </a:p>
                   </a:txBody>
-                  <a:tcPr marL="68580" marR="68580" marT="0" marB="0" anchor="t" anchorCtr="0">
+                  <a:tcPr marL="68580" marR="68580" marT="0" marB="0">
                     <a:lnL w="6350" cap="flat" cmpd="sng">
                       <a:solidFill>
                         <a:srgbClr val="000008"/>
@@ -3584,6 +3529,7 @@
                 <a:tc>
                   <a:txBody>
                     <a:bodyPr/>
+                    <a:lstStyle/>
                     <a:p>
                       <a:pPr marL="0" indent="0" algn="ctr">
                         <a:lnSpc>
@@ -3603,13 +3549,9 @@
                         </a:rPr>
                         <a:t>65564</a:t>
                       </a:r>
-                      <a:endParaRPr sz="1600" b="1">
-                        <a:latin typeface="Times New Roman" panose="02020603050405020304"/>
-                        <a:ea typeface="Times New Roman" panose="02020603050405020304"/>
-                      </a:endParaRPr>
                     </a:p>
                   </a:txBody>
-                  <a:tcPr marL="68580" marR="68580" marT="0" marB="0" anchor="t" anchorCtr="0">
+                  <a:tcPr marL="68580" marR="68580" marT="0" marB="0">
                     <a:lnL w="6350" cap="flat" cmpd="sng">
                       <a:solidFill>
                         <a:srgbClr val="000008"/>
@@ -3663,11 +3605,17 @@
                     </a:gradFill>
                   </a:tcPr>
                 </a:tc>
+                <a:extLst>
+                  <a:ext uri="{0D108BD9-81ED-4DB2-BD59-A6C34878D82A}">
+                    <a16:rowId xmlns:a16="http://schemas.microsoft.com/office/drawing/2014/main" val="10001"/>
+                  </a:ext>
+                </a:extLst>
               </a:tr>
               <a:tr h="459740">
                 <a:tc>
                   <a:txBody>
                     <a:bodyPr/>
+                    <a:lstStyle/>
                     <a:p>
                       <a:pPr marL="0" indent="0" algn="ctr">
                         <a:lnSpc>
@@ -3685,36 +3633,11 @@
                           <a:latin typeface="Times New Roman" panose="02020603050405020304"/>
                           <a:ea typeface="Times New Roman" panose="02020603050405020304"/>
                         </a:rPr>
-                        <a:t>S</a:t>
+                        <a:t>Sneh Vijaybhai Bhikadiya</a:t>
                       </a:r>
-                      <a:r>
-                        <a:rPr sz="1600" b="1">
-                          <a:latin typeface="Times New Roman" panose="02020603050405020304"/>
-                          <a:ea typeface="Times New Roman" panose="02020603050405020304"/>
-                        </a:rPr>
-                        <a:t>neh V</a:t>
-                      </a:r>
-                      <a:r>
-                        <a:rPr sz="1600" b="1">
-                          <a:latin typeface="Times New Roman" panose="02020603050405020304"/>
-                          <a:ea typeface="Times New Roman" panose="02020603050405020304"/>
-                        </a:rPr>
-                        <a:t>ijaybhai B</a:t>
-                      </a:r>
-                      <a:r>
-                        <a:rPr sz="1600" b="1">
-                          <a:latin typeface="Times New Roman" panose="02020603050405020304"/>
-                          <a:ea typeface="Times New Roman" panose="02020603050405020304"/>
-                        </a:rPr>
-                        <a:t>hikadiya</a:t>
-                      </a:r>
-                      <a:endParaRPr sz="1600" b="1">
-                        <a:latin typeface="Times New Roman" panose="02020603050405020304"/>
-                        <a:ea typeface="Times New Roman" panose="02020603050405020304"/>
-                      </a:endParaRPr>
                     </a:p>
                   </a:txBody>
-                  <a:tcPr marL="68580" marR="68580" marT="0" marB="0" anchor="t" anchorCtr="0">
+                  <a:tcPr marL="68580" marR="68580" marT="0" marB="0">
                     <a:lnL w="6350" cap="flat" cmpd="sng">
                       <a:solidFill>
                         <a:srgbClr val="000008"/>
@@ -3771,6 +3694,7 @@
                 <a:tc>
                   <a:txBody>
                     <a:bodyPr/>
+                    <a:lstStyle/>
                     <a:p>
                       <a:pPr marL="0" indent="0" algn="ctr">
                         <a:lnSpc>
@@ -3790,13 +3714,9 @@
                         </a:rPr>
                         <a:t>66186</a:t>
                       </a:r>
-                      <a:endParaRPr sz="1600" b="1">
-                        <a:latin typeface="Times New Roman" panose="02020603050405020304"/>
-                        <a:ea typeface="Times New Roman" panose="02020603050405020304"/>
-                      </a:endParaRPr>
                     </a:p>
                   </a:txBody>
-                  <a:tcPr marL="68580" marR="68580" marT="0" marB="0" anchor="t" anchorCtr="0">
+                  <a:tcPr marL="68580" marR="68580" marT="0" marB="0">
                     <a:lnL w="6350" cap="flat" cmpd="sng">
                       <a:solidFill>
                         <a:srgbClr val="000008"/>
@@ -3850,6 +3770,11 @@
                     </a:gradFill>
                   </a:tcPr>
                 </a:tc>
+                <a:extLst>
+                  <a:ext uri="{0D108BD9-81ED-4DB2-BD59-A6C34878D82A}">
+                    <a16:rowId xmlns:a16="http://schemas.microsoft.com/office/drawing/2014/main" val="10002"/>
+                  </a:ext>
+                </a:extLst>
               </a:tr>
             </a:tbl>
           </a:graphicData>
@@ -3916,6 +3841,7 @@
         </p:spPr>
         <p:txBody>
           <a:bodyPr/>
+          <a:lstStyle/>
           <a:p>
             <a:pPr marL="0" indent="0" algn="ctr">
               <a:buNone/>
@@ -3960,13 +3886,6 @@
               </a:rPr>
               <a:t>Projected Task Performance Improvements</a:t>
             </a:r>
-            <a:endParaRPr lang="en-US" sz="2600" b="1" dirty="0">
-              <a:solidFill>
-                <a:srgbClr val="FFFFFF"/>
-              </a:solidFill>
-              <a:latin typeface="Times New Roman" panose="02020603050405020304" charset="0"/>
-              <a:cs typeface="Times New Roman" panose="02020603050405020304" charset="0"/>
-            </a:endParaRPr>
           </a:p>
         </p:txBody>
       </p:sp>
@@ -4003,13 +3922,6 @@
               </a:rPr>
               <a:t>Before vs. after the redesign — projected improvements based on design changes</a:t>
             </a:r>
-            <a:endParaRPr lang="en-US" sz="1600" b="1" dirty="0">
-              <a:solidFill>
-                <a:srgbClr val="8FA3C0"/>
-              </a:solidFill>
-              <a:latin typeface="Times New Roman" panose="02020603050405020304" charset="0"/>
-              <a:cs typeface="Times New Roman" panose="02020603050405020304" charset="0"/>
-            </a:endParaRPr>
           </a:p>
         </p:txBody>
       </p:sp>
@@ -4032,16 +3944,47 @@
             <a:tbl>
               <a:tblPr/>
               <a:tblGrid>
-                <a:gridCol w="2357755"/>
-                <a:gridCol w="1407795"/>
-                <a:gridCol w="1698625"/>
-                <a:gridCol w="1362075"/>
-                <a:gridCol w="1662430"/>
+                <a:gridCol w="2357755">
+                  <a:extLst>
+                    <a:ext uri="{9D8B030D-6E8A-4147-A177-3AD203B41FA5}">
+                      <a16:colId xmlns:a16="http://schemas.microsoft.com/office/drawing/2014/main" val="20000"/>
+                    </a:ext>
+                  </a:extLst>
+                </a:gridCol>
+                <a:gridCol w="1407795">
+                  <a:extLst>
+                    <a:ext uri="{9D8B030D-6E8A-4147-A177-3AD203B41FA5}">
+                      <a16:colId xmlns:a16="http://schemas.microsoft.com/office/drawing/2014/main" val="20001"/>
+                    </a:ext>
+                  </a:extLst>
+                </a:gridCol>
+                <a:gridCol w="1698625">
+                  <a:extLst>
+                    <a:ext uri="{9D8B030D-6E8A-4147-A177-3AD203B41FA5}">
+                      <a16:colId xmlns:a16="http://schemas.microsoft.com/office/drawing/2014/main" val="20002"/>
+                    </a:ext>
+                  </a:extLst>
+                </a:gridCol>
+                <a:gridCol w="1362075">
+                  <a:extLst>
+                    <a:ext uri="{9D8B030D-6E8A-4147-A177-3AD203B41FA5}">
+                      <a16:colId xmlns:a16="http://schemas.microsoft.com/office/drawing/2014/main" val="20003"/>
+                    </a:ext>
+                  </a:extLst>
+                </a:gridCol>
+                <a:gridCol w="1662430">
+                  <a:extLst>
+                    <a:ext uri="{9D8B030D-6E8A-4147-A177-3AD203B41FA5}">
+                      <a16:colId xmlns:a16="http://schemas.microsoft.com/office/drawing/2014/main" val="20004"/>
+                    </a:ext>
+                  </a:extLst>
+                </a:gridCol>
               </a:tblGrid>
               <a:tr h="897890">
                 <a:tc>
                   <a:txBody>
                     <a:bodyPr/>
+                    <a:lstStyle/>
                     <a:p>
                       <a:pPr marL="0" indent="0">
                         <a:lnSpc>
@@ -4064,16 +4007,9 @@
                         </a:rPr>
                         <a:t>Task</a:t>
                       </a:r>
-                      <a:endParaRPr sz="1200" b="1">
-                        <a:solidFill>
-                          <a:srgbClr val="FFFFFF"/>
-                        </a:solidFill>
-                        <a:latin typeface="Times New Roman" panose="02020603050405020304"/>
-                        <a:ea typeface="SimSun" panose="02010600030101010101" pitchFamily="2" charset="-122"/>
-                      </a:endParaRPr>
                     </a:p>
                   </a:txBody>
-                  <a:tcPr marL="68580" marR="68580" marT="0" marB="0" anchor="t" anchorCtr="0">
+                  <a:tcPr marL="68580" marR="68580" marT="0" marB="0">
                     <a:lnL w="12700">
                       <a:solidFill>
                         <a:schemeClr val="tx1"/>
@@ -4112,6 +4048,7 @@
                 <a:tc>
                   <a:txBody>
                     <a:bodyPr/>
+                    <a:lstStyle/>
                     <a:p>
                       <a:pPr marL="0" indent="0">
                         <a:lnSpc>
@@ -4134,16 +4071,9 @@
                         </a:rPr>
                         <a:t>Original Rate</a:t>
                       </a:r>
-                      <a:endParaRPr sz="1200" b="1">
-                        <a:solidFill>
-                          <a:srgbClr val="FFFFFF"/>
-                        </a:solidFill>
-                        <a:latin typeface="Times New Roman" panose="02020603050405020304"/>
-                        <a:ea typeface="SimSun" panose="02010600030101010101" pitchFamily="2" charset="-122"/>
-                      </a:endParaRPr>
                     </a:p>
                   </a:txBody>
-                  <a:tcPr marL="68580" marR="68580" marT="0" marB="0" anchor="t" anchorCtr="0">
+                  <a:tcPr marL="68580" marR="68580" marT="0" marB="0">
                     <a:lnL w="12700">
                       <a:solidFill>
                         <a:schemeClr val="tx1"/>
@@ -4182,6 +4112,7 @@
                 <a:tc>
                   <a:txBody>
                     <a:bodyPr/>
+                    <a:lstStyle/>
                     <a:p>
                       <a:pPr marL="0" indent="0">
                         <a:lnSpc>
@@ -4204,16 +4135,9 @@
                         </a:rPr>
                         <a:t>Original Time</a:t>
                       </a:r>
-                      <a:endParaRPr sz="1200" b="1">
-                        <a:solidFill>
-                          <a:srgbClr val="FFFFFF"/>
-                        </a:solidFill>
-                        <a:latin typeface="Times New Roman" panose="02020603050405020304"/>
-                        <a:ea typeface="SimSun" panose="02010600030101010101" pitchFamily="2" charset="-122"/>
-                      </a:endParaRPr>
                     </a:p>
                   </a:txBody>
-                  <a:tcPr marL="68580" marR="68580" marT="0" marB="0" anchor="t" anchorCtr="0">
+                  <a:tcPr marL="68580" marR="68580" marT="0" marB="0">
                     <a:lnL w="12700">
                       <a:solidFill>
                         <a:schemeClr val="tx1"/>
@@ -4252,6 +4176,7 @@
                 <a:tc>
                   <a:txBody>
                     <a:bodyPr/>
+                    <a:lstStyle/>
                     <a:p>
                       <a:pPr marL="0" indent="0">
                         <a:lnSpc>
@@ -4274,16 +4199,9 @@
                         </a:rPr>
                         <a:t>Projected Rate</a:t>
                       </a:r>
-                      <a:endParaRPr sz="1200" b="1">
-                        <a:solidFill>
-                          <a:srgbClr val="FFFFFF"/>
-                        </a:solidFill>
-                        <a:latin typeface="Times New Roman" panose="02020603050405020304"/>
-                        <a:ea typeface="SimSun" panose="02010600030101010101" pitchFamily="2" charset="-122"/>
-                      </a:endParaRPr>
                     </a:p>
                   </a:txBody>
-                  <a:tcPr marL="68580" marR="68580" marT="0" marB="0" anchor="t" anchorCtr="0">
+                  <a:tcPr marL="68580" marR="68580" marT="0" marB="0">
                     <a:lnL w="12700">
                       <a:solidFill>
                         <a:schemeClr val="tx1"/>
@@ -4322,6 +4240,7 @@
                 <a:tc>
                   <a:txBody>
                     <a:bodyPr/>
+                    <a:lstStyle/>
                     <a:p>
                       <a:pPr marL="0" indent="0">
                         <a:lnSpc>
@@ -4344,16 +4263,9 @@
                         </a:rPr>
                         <a:t>Projected Time</a:t>
                       </a:r>
-                      <a:endParaRPr sz="1200" b="1">
-                        <a:solidFill>
-                          <a:srgbClr val="FFFFFF"/>
-                        </a:solidFill>
-                        <a:latin typeface="Times New Roman" panose="02020603050405020304"/>
-                        <a:ea typeface="SimSun" panose="02010600030101010101" pitchFamily="2" charset="-122"/>
-                      </a:endParaRPr>
                     </a:p>
                   </a:txBody>
-                  <a:tcPr marL="68580" marR="68580" marT="0" marB="0" anchor="t" anchorCtr="0">
+                  <a:tcPr marL="68580" marR="68580" marT="0" marB="0">
                     <a:lnL w="12700">
                       <a:solidFill>
                         <a:schemeClr val="tx1"/>
@@ -4389,11 +4301,17 @@
                     </a:solidFill>
                   </a:tcPr>
                 </a:tc>
+                <a:extLst>
+                  <a:ext uri="{0D108BD9-81ED-4DB2-BD59-A6C34878D82A}">
+                    <a16:rowId xmlns:a16="http://schemas.microsoft.com/office/drawing/2014/main" val="10000"/>
+                  </a:ext>
+                </a:extLst>
               </a:tr>
               <a:tr h="896620">
                 <a:tc>
                   <a:txBody>
                     <a:bodyPr/>
+                    <a:lstStyle/>
                     <a:p>
                       <a:pPr marL="0" indent="0">
                         <a:lnSpc>
@@ -4416,16 +4334,9 @@
                         </a:rPr>
                         <a:t>Search Cryptocurrency</a:t>
                       </a:r>
-                      <a:endParaRPr sz="1200" b="1">
-                        <a:solidFill>
-                          <a:srgbClr val="FFFFFF"/>
-                        </a:solidFill>
-                        <a:latin typeface="Times New Roman" panose="02020603050405020304"/>
-                        <a:ea typeface="SimSun" panose="02010600030101010101" pitchFamily="2" charset="-122"/>
-                      </a:endParaRPr>
                     </a:p>
                   </a:txBody>
-                  <a:tcPr marL="68580" marR="68580" marT="0" marB="0" anchor="t" anchorCtr="0">
+                  <a:tcPr marL="68580" marR="68580" marT="0" marB="0">
                     <a:lnL w="12700">
                       <a:solidFill>
                         <a:schemeClr val="tx1"/>
@@ -4464,6 +4375,7 @@
                 <a:tc>
                   <a:txBody>
                     <a:bodyPr/>
+                    <a:lstStyle/>
                     <a:p>
                       <a:pPr marL="0" indent="0">
                         <a:lnSpc>
@@ -4486,16 +4398,9 @@
                         </a:rPr>
                         <a:t>100%</a:t>
                       </a:r>
-                      <a:endParaRPr sz="1200">
-                        <a:solidFill>
-                          <a:srgbClr val="FFFFFF"/>
-                        </a:solidFill>
-                        <a:latin typeface="Times New Roman" panose="02020603050405020304"/>
-                        <a:ea typeface="SimSun" panose="02010600030101010101" pitchFamily="2" charset="-122"/>
-                      </a:endParaRPr>
                     </a:p>
                   </a:txBody>
-                  <a:tcPr marL="68580" marR="68580" marT="0" marB="0" anchor="t" anchorCtr="0">
+                  <a:tcPr marL="68580" marR="68580" marT="0" marB="0">
                     <a:lnL w="12700">
                       <a:solidFill>
                         <a:schemeClr val="tx1"/>
@@ -4534,6 +4439,7 @@
                 <a:tc>
                   <a:txBody>
                     <a:bodyPr/>
+                    <a:lstStyle/>
                     <a:p>
                       <a:pPr marL="0" indent="0">
                         <a:lnSpc>
@@ -4556,16 +4462,9 @@
                         </a:rPr>
                         <a:t>35 sec</a:t>
                       </a:r>
-                      <a:endParaRPr sz="1200">
-                        <a:solidFill>
-                          <a:srgbClr val="FFFFFF"/>
-                        </a:solidFill>
-                        <a:latin typeface="Times New Roman" panose="02020603050405020304"/>
-                        <a:ea typeface="SimSun" panose="02010600030101010101" pitchFamily="2" charset="-122"/>
-                      </a:endParaRPr>
                     </a:p>
                   </a:txBody>
-                  <a:tcPr marL="68580" marR="68580" marT="0" marB="0" anchor="t" anchorCtr="0">
+                  <a:tcPr marL="68580" marR="68580" marT="0" marB="0">
                     <a:lnL w="12700">
                       <a:solidFill>
                         <a:schemeClr val="tx1"/>
@@ -4604,6 +4503,7 @@
                 <a:tc>
                   <a:txBody>
                     <a:bodyPr/>
+                    <a:lstStyle/>
                     <a:p>
                       <a:pPr marL="0" indent="0">
                         <a:lnSpc>
@@ -4626,16 +4526,9 @@
                         </a:rPr>
                         <a:t>100%</a:t>
                       </a:r>
-                      <a:endParaRPr sz="1200">
-                        <a:solidFill>
-                          <a:srgbClr val="FFFFFF"/>
-                        </a:solidFill>
-                        <a:latin typeface="Times New Roman" panose="02020603050405020304"/>
-                        <a:ea typeface="SimSun" panose="02010600030101010101" pitchFamily="2" charset="-122"/>
-                      </a:endParaRPr>
                     </a:p>
                   </a:txBody>
-                  <a:tcPr marL="68580" marR="68580" marT="0" marB="0" anchor="t" anchorCtr="0">
+                  <a:tcPr marL="68580" marR="68580" marT="0" marB="0">
                     <a:lnL w="12700">
                       <a:solidFill>
                         <a:schemeClr val="tx1"/>
@@ -4674,6 +4567,7 @@
                 <a:tc>
                   <a:txBody>
                     <a:bodyPr/>
+                    <a:lstStyle/>
                     <a:p>
                       <a:pPr marL="0" indent="0">
                         <a:lnSpc>
@@ -4696,16 +4590,9 @@
                         </a:rPr>
                         <a:t>20 sec</a:t>
                       </a:r>
-                      <a:endParaRPr sz="1200">
-                        <a:solidFill>
-                          <a:srgbClr val="FFFFFF"/>
-                        </a:solidFill>
-                        <a:latin typeface="Times New Roman" panose="02020603050405020304"/>
-                        <a:ea typeface="SimSun" panose="02010600030101010101" pitchFamily="2" charset="-122"/>
-                      </a:endParaRPr>
                     </a:p>
                   </a:txBody>
-                  <a:tcPr marL="68580" marR="68580" marT="0" marB="0" anchor="t" anchorCtr="0">
+                  <a:tcPr marL="68580" marR="68580" marT="0" marB="0">
                     <a:lnL w="12700">
                       <a:solidFill>
                         <a:schemeClr val="tx1"/>
@@ -4741,11 +4628,17 @@
                     </a:solidFill>
                   </a:tcPr>
                 </a:tc>
+                <a:extLst>
+                  <a:ext uri="{0D108BD9-81ED-4DB2-BD59-A6C34878D82A}">
+                    <a16:rowId xmlns:a16="http://schemas.microsoft.com/office/drawing/2014/main" val="10001"/>
+                  </a:ext>
+                </a:extLst>
               </a:tr>
               <a:tr h="448945">
                 <a:tc>
                   <a:txBody>
                     <a:bodyPr/>
+                    <a:lstStyle/>
                     <a:p>
                       <a:pPr marL="0" indent="0">
                         <a:lnSpc>
@@ -4768,16 +4661,9 @@
                         </a:rPr>
                         <a:t>Buy Cryptocurrency</a:t>
                       </a:r>
-                      <a:endParaRPr sz="1200" b="1">
-                        <a:solidFill>
-                          <a:srgbClr val="FFFFFF"/>
-                        </a:solidFill>
-                        <a:latin typeface="Times New Roman" panose="02020603050405020304"/>
-                        <a:ea typeface="SimSun" panose="02010600030101010101" pitchFamily="2" charset="-122"/>
-                      </a:endParaRPr>
                     </a:p>
                   </a:txBody>
-                  <a:tcPr marL="68580" marR="68580" marT="0" marB="0" anchor="t" anchorCtr="0">
+                  <a:tcPr marL="68580" marR="68580" marT="0" marB="0">
                     <a:lnL w="12700">
                       <a:solidFill>
                         <a:schemeClr val="tx1"/>
@@ -4816,6 +4702,7 @@
                 <a:tc>
                   <a:txBody>
                     <a:bodyPr/>
+                    <a:lstStyle/>
                     <a:p>
                       <a:pPr marL="0" indent="0">
                         <a:lnSpc>
@@ -4838,16 +4725,9 @@
                         </a:rPr>
                         <a:t>90%</a:t>
                       </a:r>
-                      <a:endParaRPr sz="1200">
-                        <a:solidFill>
-                          <a:srgbClr val="FFFFFF"/>
-                        </a:solidFill>
-                        <a:latin typeface="Times New Roman" panose="02020603050405020304"/>
-                        <a:ea typeface="SimSun" panose="02010600030101010101" pitchFamily="2" charset="-122"/>
-                      </a:endParaRPr>
                     </a:p>
                   </a:txBody>
-                  <a:tcPr marL="68580" marR="68580" marT="0" marB="0" anchor="t" anchorCtr="0">
+                  <a:tcPr marL="68580" marR="68580" marT="0" marB="0">
                     <a:lnL w="12700">
                       <a:solidFill>
                         <a:schemeClr val="tx1"/>
@@ -4886,6 +4766,7 @@
                 <a:tc>
                   <a:txBody>
                     <a:bodyPr/>
+                    <a:lstStyle/>
                     <a:p>
                       <a:pPr marL="0" indent="0">
                         <a:lnSpc>
@@ -4908,16 +4789,9 @@
                         </a:rPr>
                         <a:t>1 min 40 sec</a:t>
                       </a:r>
-                      <a:endParaRPr sz="1200">
-                        <a:solidFill>
-                          <a:srgbClr val="FFFFFF"/>
-                        </a:solidFill>
-                        <a:latin typeface="Times New Roman" panose="02020603050405020304"/>
-                        <a:ea typeface="SimSun" panose="02010600030101010101" pitchFamily="2" charset="-122"/>
-                      </a:endParaRPr>
                     </a:p>
                   </a:txBody>
-                  <a:tcPr marL="68580" marR="68580" marT="0" marB="0" anchor="t" anchorCtr="0">
+                  <a:tcPr marL="68580" marR="68580" marT="0" marB="0">
                     <a:lnL w="12700">
                       <a:solidFill>
                         <a:schemeClr val="tx1"/>
@@ -4956,6 +4830,7 @@
                 <a:tc>
                   <a:txBody>
                     <a:bodyPr/>
+                    <a:lstStyle/>
                     <a:p>
                       <a:pPr marL="0" indent="0">
                         <a:lnSpc>
@@ -4978,16 +4853,9 @@
                         </a:rPr>
                         <a:t>95%</a:t>
                       </a:r>
-                      <a:endParaRPr sz="1200">
-                        <a:solidFill>
-                          <a:srgbClr val="FFFFFF"/>
-                        </a:solidFill>
-                        <a:latin typeface="Times New Roman" panose="02020603050405020304"/>
-                        <a:ea typeface="SimSun" panose="02010600030101010101" pitchFamily="2" charset="-122"/>
-                      </a:endParaRPr>
                     </a:p>
                   </a:txBody>
-                  <a:tcPr marL="68580" marR="68580" marT="0" marB="0" anchor="t" anchorCtr="0">
+                  <a:tcPr marL="68580" marR="68580" marT="0" marB="0">
                     <a:lnL w="12700">
                       <a:solidFill>
                         <a:schemeClr val="tx1"/>
@@ -5026,6 +4894,7 @@
                 <a:tc>
                   <a:txBody>
                     <a:bodyPr/>
+                    <a:lstStyle/>
                     <a:p>
                       <a:pPr marL="0" indent="0">
                         <a:lnSpc>
@@ -5048,16 +4917,9 @@
                         </a:rPr>
                         <a:t>55 sec</a:t>
                       </a:r>
-                      <a:endParaRPr sz="1200">
-                        <a:solidFill>
-                          <a:srgbClr val="FFFFFF"/>
-                        </a:solidFill>
-                        <a:latin typeface="Times New Roman" panose="02020603050405020304"/>
-                        <a:ea typeface="SimSun" panose="02010600030101010101" pitchFamily="2" charset="-122"/>
-                      </a:endParaRPr>
                     </a:p>
                   </a:txBody>
-                  <a:tcPr marL="68580" marR="68580" marT="0" marB="0" anchor="t" anchorCtr="0">
+                  <a:tcPr marL="68580" marR="68580" marT="0" marB="0">
                     <a:lnL w="12700">
                       <a:solidFill>
                         <a:schemeClr val="tx1"/>
@@ -5093,11 +4955,17 @@
                     </a:solidFill>
                   </a:tcPr>
                 </a:tc>
+                <a:extLst>
+                  <a:ext uri="{0D108BD9-81ED-4DB2-BD59-A6C34878D82A}">
+                    <a16:rowId xmlns:a16="http://schemas.microsoft.com/office/drawing/2014/main" val="10002"/>
+                  </a:ext>
+                </a:extLst>
               </a:tr>
               <a:tr h="448310">
                 <a:tc>
                   <a:txBody>
                     <a:bodyPr/>
+                    <a:lstStyle/>
                     <a:p>
                       <a:pPr marL="0" indent="0">
                         <a:lnSpc>
@@ -5120,16 +4988,9 @@
                         </a:rPr>
                         <a:t>Sell Stock</a:t>
                       </a:r>
-                      <a:endParaRPr sz="1200" b="1">
-                        <a:solidFill>
-                          <a:srgbClr val="FFFFFF"/>
-                        </a:solidFill>
-                        <a:latin typeface="Times New Roman" panose="02020603050405020304"/>
-                        <a:ea typeface="SimSun" panose="02010600030101010101" pitchFamily="2" charset="-122"/>
-                      </a:endParaRPr>
                     </a:p>
                   </a:txBody>
-                  <a:tcPr marL="68580" marR="68580" marT="0" marB="0" anchor="t" anchorCtr="0">
+                  <a:tcPr marL="68580" marR="68580" marT="0" marB="0">
                     <a:lnL w="12700">
                       <a:solidFill>
                         <a:schemeClr val="tx1"/>
@@ -5168,6 +5029,7 @@
                 <a:tc>
                   <a:txBody>
                     <a:bodyPr/>
+                    <a:lstStyle/>
                     <a:p>
                       <a:pPr marL="0" indent="0">
                         <a:lnSpc>
@@ -5190,16 +5052,9 @@
                         </a:rPr>
                         <a:t>80%</a:t>
                       </a:r>
-                      <a:endParaRPr sz="1200">
-                        <a:solidFill>
-                          <a:srgbClr val="FFFFFF"/>
-                        </a:solidFill>
-                        <a:latin typeface="Times New Roman" panose="02020603050405020304"/>
-                        <a:ea typeface="SimSun" panose="02010600030101010101" pitchFamily="2" charset="-122"/>
-                      </a:endParaRPr>
                     </a:p>
                   </a:txBody>
-                  <a:tcPr marL="68580" marR="68580" marT="0" marB="0" anchor="t" anchorCtr="0">
+                  <a:tcPr marL="68580" marR="68580" marT="0" marB="0">
                     <a:lnL w="12700">
                       <a:solidFill>
                         <a:schemeClr val="tx1"/>
@@ -5238,6 +5093,7 @@
                 <a:tc>
                   <a:txBody>
                     <a:bodyPr/>
+                    <a:lstStyle/>
                     <a:p>
                       <a:pPr marL="0" indent="0">
                         <a:lnSpc>
@@ -5260,16 +5116,9 @@
                         </a:rPr>
                         <a:t>2 min</a:t>
                       </a:r>
-                      <a:endParaRPr sz="1200">
-                        <a:solidFill>
-                          <a:srgbClr val="FFFFFF"/>
-                        </a:solidFill>
-                        <a:latin typeface="Times New Roman" panose="02020603050405020304"/>
-                        <a:ea typeface="SimSun" panose="02010600030101010101" pitchFamily="2" charset="-122"/>
-                      </a:endParaRPr>
                     </a:p>
                   </a:txBody>
-                  <a:tcPr marL="68580" marR="68580" marT="0" marB="0" anchor="t" anchorCtr="0">
+                  <a:tcPr marL="68580" marR="68580" marT="0" marB="0">
                     <a:lnL w="12700">
                       <a:solidFill>
                         <a:schemeClr val="tx1"/>
@@ -5308,6 +5157,7 @@
                 <a:tc>
                   <a:txBody>
                     <a:bodyPr/>
+                    <a:lstStyle/>
                     <a:p>
                       <a:pPr marL="0" indent="0">
                         <a:lnSpc>
@@ -5330,16 +5180,9 @@
                         </a:rPr>
                         <a:t>92%</a:t>
                       </a:r>
-                      <a:endParaRPr sz="1200">
-                        <a:solidFill>
-                          <a:srgbClr val="FFFFFF"/>
-                        </a:solidFill>
-                        <a:latin typeface="Times New Roman" panose="02020603050405020304"/>
-                        <a:ea typeface="SimSun" panose="02010600030101010101" pitchFamily="2" charset="-122"/>
-                      </a:endParaRPr>
                     </a:p>
                   </a:txBody>
-                  <a:tcPr marL="68580" marR="68580" marT="0" marB="0" anchor="t" anchorCtr="0">
+                  <a:tcPr marL="68580" marR="68580" marT="0" marB="0">
                     <a:lnL w="12700">
                       <a:solidFill>
                         <a:schemeClr val="tx1"/>
@@ -5378,6 +5221,7 @@
                 <a:tc>
                   <a:txBody>
                     <a:bodyPr/>
+                    <a:lstStyle/>
                     <a:p>
                       <a:pPr marL="0" indent="0">
                         <a:lnSpc>
@@ -5400,16 +5244,9 @@
                         </a:rPr>
                         <a:t>1 min 10 sec</a:t>
                       </a:r>
-                      <a:endParaRPr sz="1200">
-                        <a:solidFill>
-                          <a:srgbClr val="FFFFFF"/>
-                        </a:solidFill>
-                        <a:latin typeface="Times New Roman" panose="02020603050405020304"/>
-                        <a:ea typeface="SimSun" panose="02010600030101010101" pitchFamily="2" charset="-122"/>
-                      </a:endParaRPr>
                     </a:p>
                   </a:txBody>
-                  <a:tcPr marL="68580" marR="68580" marT="0" marB="0" anchor="t" anchorCtr="0">
+                  <a:tcPr marL="68580" marR="68580" marT="0" marB="0">
                     <a:lnL w="12700">
                       <a:solidFill>
                         <a:schemeClr val="tx1"/>
@@ -5445,11 +5282,17 @@
                     </a:solidFill>
                   </a:tcPr>
                 </a:tc>
+                <a:extLst>
+                  <a:ext uri="{0D108BD9-81ED-4DB2-BD59-A6C34878D82A}">
+                    <a16:rowId xmlns:a16="http://schemas.microsoft.com/office/drawing/2014/main" val="10003"/>
+                  </a:ext>
+                </a:extLst>
               </a:tr>
               <a:tr h="448310">
                 <a:tc>
                   <a:txBody>
                     <a:bodyPr/>
+                    <a:lstStyle/>
                     <a:p>
                       <a:pPr marL="0" indent="0">
                         <a:lnSpc>
@@ -5472,16 +5315,9 @@
                         </a:rPr>
                         <a:t>Transfer Funds</a:t>
                       </a:r>
-                      <a:endParaRPr sz="1200" b="1">
-                        <a:solidFill>
-                          <a:srgbClr val="FFFFFF"/>
-                        </a:solidFill>
-                        <a:latin typeface="Times New Roman" panose="02020603050405020304"/>
-                        <a:ea typeface="SimSun" panose="02010600030101010101" pitchFamily="2" charset="-122"/>
-                      </a:endParaRPr>
                     </a:p>
                   </a:txBody>
-                  <a:tcPr marL="68580" marR="68580" marT="0" marB="0" anchor="t" anchorCtr="0">
+                  <a:tcPr marL="68580" marR="68580" marT="0" marB="0">
                     <a:lnL w="12700">
                       <a:solidFill>
                         <a:schemeClr val="tx1"/>
@@ -5520,6 +5356,7 @@
                 <a:tc>
                   <a:txBody>
                     <a:bodyPr/>
+                    <a:lstStyle/>
                     <a:p>
                       <a:pPr marL="0" indent="0">
                         <a:lnSpc>
@@ -5542,16 +5379,9 @@
                         </a:rPr>
                         <a:t>70%</a:t>
                       </a:r>
-                      <a:endParaRPr sz="1200">
-                        <a:solidFill>
-                          <a:srgbClr val="FFFFFF"/>
-                        </a:solidFill>
-                        <a:latin typeface="Times New Roman" panose="02020603050405020304"/>
-                        <a:ea typeface="SimSun" panose="02010600030101010101" pitchFamily="2" charset="-122"/>
-                      </a:endParaRPr>
                     </a:p>
                   </a:txBody>
-                  <a:tcPr marL="68580" marR="68580" marT="0" marB="0" anchor="t" anchorCtr="0">
+                  <a:tcPr marL="68580" marR="68580" marT="0" marB="0">
                     <a:lnL w="12700">
                       <a:solidFill>
                         <a:schemeClr val="tx1"/>
@@ -5590,6 +5420,7 @@
                 <a:tc>
                   <a:txBody>
                     <a:bodyPr/>
+                    <a:lstStyle/>
                     <a:p>
                       <a:pPr marL="0" indent="0">
                         <a:lnSpc>
@@ -5612,16 +5443,9 @@
                         </a:rPr>
                         <a:t>2 min 30 sec</a:t>
                       </a:r>
-                      <a:endParaRPr sz="1200">
-                        <a:solidFill>
-                          <a:srgbClr val="FFFFFF"/>
-                        </a:solidFill>
-                        <a:latin typeface="Times New Roman" panose="02020603050405020304"/>
-                        <a:ea typeface="SimSun" panose="02010600030101010101" pitchFamily="2" charset="-122"/>
-                      </a:endParaRPr>
                     </a:p>
                   </a:txBody>
-                  <a:tcPr marL="68580" marR="68580" marT="0" marB="0" anchor="t" anchorCtr="0">
+                  <a:tcPr marL="68580" marR="68580" marT="0" marB="0">
                     <a:lnL w="12700">
                       <a:solidFill>
                         <a:schemeClr val="tx1"/>
@@ -5660,6 +5484,7 @@
                 <a:tc>
                   <a:txBody>
                     <a:bodyPr/>
+                    <a:lstStyle/>
                     <a:p>
                       <a:pPr marL="0" indent="0">
                         <a:lnSpc>
@@ -5682,16 +5507,9 @@
                         </a:rPr>
                         <a:t>90%</a:t>
                       </a:r>
-                      <a:endParaRPr sz="1200">
-                        <a:solidFill>
-                          <a:srgbClr val="FFFFFF"/>
-                        </a:solidFill>
-                        <a:latin typeface="Times New Roman" panose="02020603050405020304"/>
-                        <a:ea typeface="SimSun" panose="02010600030101010101" pitchFamily="2" charset="-122"/>
-                      </a:endParaRPr>
                     </a:p>
                   </a:txBody>
-                  <a:tcPr marL="68580" marR="68580" marT="0" marB="0" anchor="t" anchorCtr="0">
+                  <a:tcPr marL="68580" marR="68580" marT="0" marB="0">
                     <a:lnL w="12700">
                       <a:solidFill>
                         <a:schemeClr val="tx1"/>
@@ -5730,6 +5548,7 @@
                 <a:tc>
                   <a:txBody>
                     <a:bodyPr/>
+                    <a:lstStyle/>
                     <a:p>
                       <a:pPr marL="0" indent="0">
                         <a:lnSpc>
@@ -5752,16 +5571,9 @@
                         </a:rPr>
                         <a:t>1 min 20 sec</a:t>
                       </a:r>
-                      <a:endParaRPr sz="1200">
-                        <a:solidFill>
-                          <a:srgbClr val="FFFFFF"/>
-                        </a:solidFill>
-                        <a:latin typeface="Times New Roman" panose="02020603050405020304"/>
-                        <a:ea typeface="SimSun" panose="02010600030101010101" pitchFamily="2" charset="-122"/>
-                      </a:endParaRPr>
                     </a:p>
                   </a:txBody>
-                  <a:tcPr marL="68580" marR="68580" marT="0" marB="0" anchor="t" anchorCtr="0">
+                  <a:tcPr marL="68580" marR="68580" marT="0" marB="0">
                     <a:lnL w="12700">
                       <a:solidFill>
                         <a:schemeClr val="tx1"/>
@@ -5797,11 +5609,17 @@
                     </a:solidFill>
                   </a:tcPr>
                 </a:tc>
+                <a:extLst>
+                  <a:ext uri="{0D108BD9-81ED-4DB2-BD59-A6C34878D82A}">
+                    <a16:rowId xmlns:a16="http://schemas.microsoft.com/office/drawing/2014/main" val="10004"/>
+                  </a:ext>
+                </a:extLst>
               </a:tr>
               <a:tr h="449580">
                 <a:tc>
                   <a:txBody>
                     <a:bodyPr/>
+                    <a:lstStyle/>
                     <a:p>
                       <a:pPr marL="0" indent="0">
                         <a:lnSpc>
@@ -5824,16 +5642,9 @@
                         </a:rPr>
                         <a:t>Setup Auto-Trading</a:t>
                       </a:r>
-                      <a:endParaRPr sz="1200" b="1">
-                        <a:solidFill>
-                          <a:srgbClr val="FFFFFF"/>
-                        </a:solidFill>
-                        <a:latin typeface="Times New Roman" panose="02020603050405020304"/>
-                        <a:ea typeface="SimSun" panose="02010600030101010101" pitchFamily="2" charset="-122"/>
-                      </a:endParaRPr>
                     </a:p>
                   </a:txBody>
-                  <a:tcPr marL="68580" marR="68580" marT="0" marB="0" anchor="t" anchorCtr="0">
+                  <a:tcPr marL="68580" marR="68580" marT="0" marB="0">
                     <a:lnL w="12700">
                       <a:solidFill>
                         <a:schemeClr val="tx1"/>
@@ -5872,6 +5683,7 @@
                 <a:tc>
                   <a:txBody>
                     <a:bodyPr/>
+                    <a:lstStyle/>
                     <a:p>
                       <a:pPr marL="0" indent="0">
                         <a:lnSpc>
@@ -5894,16 +5706,9 @@
                         </a:rPr>
                         <a:t>60%</a:t>
                       </a:r>
-                      <a:endParaRPr sz="1200">
-                        <a:solidFill>
-                          <a:srgbClr val="FFFFFF"/>
-                        </a:solidFill>
-                        <a:latin typeface="Times New Roman" panose="02020603050405020304"/>
-                        <a:ea typeface="SimSun" panose="02010600030101010101" pitchFamily="2" charset="-122"/>
-                      </a:endParaRPr>
                     </a:p>
                   </a:txBody>
-                  <a:tcPr marL="68580" marR="68580" marT="0" marB="0" anchor="t" anchorCtr="0">
+                  <a:tcPr marL="68580" marR="68580" marT="0" marB="0">
                     <a:lnL w="12700">
                       <a:solidFill>
                         <a:schemeClr val="tx1"/>
@@ -5942,6 +5747,7 @@
                 <a:tc>
                   <a:txBody>
                     <a:bodyPr/>
+                    <a:lstStyle/>
                     <a:p>
                       <a:pPr marL="0" indent="0">
                         <a:lnSpc>
@@ -5964,16 +5770,9 @@
                         </a:rPr>
                         <a:t>3 min 20 sec</a:t>
                       </a:r>
-                      <a:endParaRPr sz="1200">
-                        <a:solidFill>
-                          <a:srgbClr val="FFFFFF"/>
-                        </a:solidFill>
-                        <a:latin typeface="Times New Roman" panose="02020603050405020304"/>
-                        <a:ea typeface="SimSun" panose="02010600030101010101" pitchFamily="2" charset="-122"/>
-                      </a:endParaRPr>
                     </a:p>
                   </a:txBody>
-                  <a:tcPr marL="68580" marR="68580" marT="0" marB="0" anchor="t" anchorCtr="0">
+                  <a:tcPr marL="68580" marR="68580" marT="0" marB="0">
                     <a:lnL w="12700">
                       <a:solidFill>
                         <a:schemeClr val="tx1"/>
@@ -6012,6 +5811,7 @@
                 <a:tc>
                   <a:txBody>
                     <a:bodyPr/>
+                    <a:lstStyle/>
                     <a:p>
                       <a:pPr marL="0" indent="0">
                         <a:lnSpc>
@@ -6034,16 +5834,9 @@
                         </a:rPr>
                         <a:t>85%</a:t>
                       </a:r>
-                      <a:endParaRPr sz="1200">
-                        <a:solidFill>
-                          <a:srgbClr val="FFFFFF"/>
-                        </a:solidFill>
-                        <a:latin typeface="Times New Roman" panose="02020603050405020304"/>
-                        <a:ea typeface="SimSun" panose="02010600030101010101" pitchFamily="2" charset="-122"/>
-                      </a:endParaRPr>
                     </a:p>
                   </a:txBody>
-                  <a:tcPr marL="68580" marR="68580" marT="0" marB="0" anchor="t" anchorCtr="0">
+                  <a:tcPr marL="68580" marR="68580" marT="0" marB="0">
                     <a:lnL w="12700">
                       <a:solidFill>
                         <a:schemeClr val="tx1"/>
@@ -6082,6 +5875,7 @@
                 <a:tc>
                   <a:txBody>
                     <a:bodyPr/>
+                    <a:lstStyle/>
                     <a:p>
                       <a:pPr marL="0" indent="0">
                         <a:lnSpc>
@@ -6104,16 +5898,9 @@
                         </a:rPr>
                         <a:t>1 min 50 sec</a:t>
                       </a:r>
-                      <a:endParaRPr sz="1200">
-                        <a:solidFill>
-                          <a:srgbClr val="FFFFFF"/>
-                        </a:solidFill>
-                        <a:latin typeface="Times New Roman" panose="02020603050405020304"/>
-                        <a:ea typeface="SimSun" panose="02010600030101010101" pitchFamily="2" charset="-122"/>
-                      </a:endParaRPr>
                     </a:p>
                   </a:txBody>
-                  <a:tcPr marL="68580" marR="68580" marT="0" marB="0" anchor="t" anchorCtr="0">
+                  <a:tcPr marL="68580" marR="68580" marT="0" marB="0">
                     <a:lnL w="12700">
                       <a:solidFill>
                         <a:schemeClr val="tx1"/>
@@ -6149,11 +5936,17 @@
                     </a:solidFill>
                   </a:tcPr>
                 </a:tc>
+                <a:extLst>
+                  <a:ext uri="{0D108BD9-81ED-4DB2-BD59-A6C34878D82A}">
+                    <a16:rowId xmlns:a16="http://schemas.microsoft.com/office/drawing/2014/main" val="10005"/>
+                  </a:ext>
+                </a:extLst>
               </a:tr>
               <a:tr h="448310">
                 <a:tc>
                   <a:txBody>
                     <a:bodyPr/>
+                    <a:lstStyle/>
                     <a:p>
                       <a:pPr marL="0" indent="0">
                         <a:lnSpc>
@@ -6176,16 +5969,9 @@
                         </a:rPr>
                         <a:t>Chatbot Interaction</a:t>
                       </a:r>
-                      <a:endParaRPr sz="1200" b="1">
-                        <a:solidFill>
-                          <a:srgbClr val="FFFFFF"/>
-                        </a:solidFill>
-                        <a:latin typeface="Times New Roman" panose="02020603050405020304"/>
-                        <a:ea typeface="SimSun" panose="02010600030101010101" pitchFamily="2" charset="-122"/>
-                      </a:endParaRPr>
                     </a:p>
                   </a:txBody>
-                  <a:tcPr marL="68580" marR="68580" marT="0" marB="0" anchor="t" anchorCtr="0">
+                  <a:tcPr marL="68580" marR="68580" marT="0" marB="0">
                     <a:lnL w="12700">
                       <a:solidFill>
                         <a:schemeClr val="tx1"/>
@@ -6224,6 +6010,7 @@
                 <a:tc>
                   <a:txBody>
                     <a:bodyPr/>
+                    <a:lstStyle/>
                     <a:p>
                       <a:pPr marL="0" indent="0">
                         <a:lnSpc>
@@ -6246,16 +6033,9 @@
                         </a:rPr>
                         <a:t>90%</a:t>
                       </a:r>
-                      <a:endParaRPr sz="1200">
-                        <a:solidFill>
-                          <a:srgbClr val="FFFFFF"/>
-                        </a:solidFill>
-                        <a:latin typeface="Times New Roman" panose="02020603050405020304"/>
-                        <a:ea typeface="SimSun" panose="02010600030101010101" pitchFamily="2" charset="-122"/>
-                      </a:endParaRPr>
                     </a:p>
                   </a:txBody>
-                  <a:tcPr marL="68580" marR="68580" marT="0" marB="0" anchor="t" anchorCtr="0">
+                  <a:tcPr marL="68580" marR="68580" marT="0" marB="0">
                     <a:lnL w="12700">
                       <a:solidFill>
                         <a:schemeClr val="tx1"/>
@@ -6294,6 +6074,7 @@
                 <a:tc>
                   <a:txBody>
                     <a:bodyPr/>
+                    <a:lstStyle/>
                     <a:p>
                       <a:pPr marL="0" indent="0">
                         <a:lnSpc>
@@ -6316,16 +6097,9 @@
                         </a:rPr>
                         <a:t>50 sec</a:t>
                       </a:r>
-                      <a:endParaRPr sz="1200">
-                        <a:solidFill>
-                          <a:srgbClr val="FFFFFF"/>
-                        </a:solidFill>
-                        <a:latin typeface="Times New Roman" panose="02020603050405020304"/>
-                        <a:ea typeface="SimSun" panose="02010600030101010101" pitchFamily="2" charset="-122"/>
-                      </a:endParaRPr>
                     </a:p>
                   </a:txBody>
-                  <a:tcPr marL="68580" marR="68580" marT="0" marB="0" anchor="t" anchorCtr="0">
+                  <a:tcPr marL="68580" marR="68580" marT="0" marB="0">
                     <a:lnL w="12700">
                       <a:solidFill>
                         <a:schemeClr val="tx1"/>
@@ -6364,6 +6138,7 @@
                 <a:tc>
                   <a:txBody>
                     <a:bodyPr/>
+                    <a:lstStyle/>
                     <a:p>
                       <a:pPr marL="0" indent="0">
                         <a:lnSpc>
@@ -6386,16 +6161,9 @@
                         </a:rPr>
                         <a:t>95%</a:t>
                       </a:r>
-                      <a:endParaRPr sz="1200">
-                        <a:solidFill>
-                          <a:srgbClr val="FFFFFF"/>
-                        </a:solidFill>
-                        <a:latin typeface="Times New Roman" panose="02020603050405020304"/>
-                        <a:ea typeface="SimSun" panose="02010600030101010101" pitchFamily="2" charset="-122"/>
-                      </a:endParaRPr>
                     </a:p>
                   </a:txBody>
-                  <a:tcPr marL="68580" marR="68580" marT="0" marB="0" anchor="t" anchorCtr="0">
+                  <a:tcPr marL="68580" marR="68580" marT="0" marB="0">
                     <a:lnL w="12700">
                       <a:solidFill>
                         <a:schemeClr val="tx1"/>
@@ -6434,6 +6202,7 @@
                 <a:tc>
                   <a:txBody>
                     <a:bodyPr/>
+                    <a:lstStyle/>
                     <a:p>
                       <a:pPr marL="0" indent="0">
                         <a:lnSpc>
@@ -6456,16 +6225,9 @@
                         </a:rPr>
                         <a:t>35 sec</a:t>
                       </a:r>
-                      <a:endParaRPr sz="1200">
-                        <a:solidFill>
-                          <a:srgbClr val="FFFFFF"/>
-                        </a:solidFill>
-                        <a:latin typeface="Times New Roman" panose="02020603050405020304"/>
-                        <a:ea typeface="SimSun" panose="02010600030101010101" pitchFamily="2" charset="-122"/>
-                      </a:endParaRPr>
                     </a:p>
                   </a:txBody>
-                  <a:tcPr marL="68580" marR="68580" marT="0" marB="0" anchor="t" anchorCtr="0">
+                  <a:tcPr marL="68580" marR="68580" marT="0" marB="0">
                     <a:lnL w="12700">
                       <a:solidFill>
                         <a:schemeClr val="tx1"/>
@@ -6501,6 +6263,11 @@
                     </a:solidFill>
                   </a:tcPr>
                 </a:tc>
+                <a:extLst>
+                  <a:ext uri="{0D108BD9-81ED-4DB2-BD59-A6C34878D82A}">
+                    <a16:rowId xmlns:a16="http://schemas.microsoft.com/office/drawing/2014/main" val="10006"/>
+                  </a:ext>
+                </a:extLst>
               </a:tr>
             </a:tbl>
           </a:graphicData>
@@ -6515,7 +6282,7 @@
           <p:nvPr/>
         </p:nvPicPr>
         <p:blipFill>
-          <a:blip r:embed="rId2"/>
+          <a:blip r:embed="rId3"/>
           <a:stretch>
             <a:fillRect/>
           </a:stretch>
@@ -6591,6 +6358,7 @@
         </p:spPr>
         <p:txBody>
           <a:bodyPr/>
+          <a:lstStyle/>
           <a:p>
             <a:pPr marL="0" indent="0" algn="ctr">
               <a:buNone/>
@@ -6635,13 +6403,6 @@
               </a:rPr>
               <a:t>Accessibility &amp; Conclusion</a:t>
             </a:r>
-            <a:endParaRPr lang="en-US" sz="2800" b="1" dirty="0">
-              <a:solidFill>
-                <a:srgbClr val="FFFFFF"/>
-              </a:solidFill>
-              <a:latin typeface="Times New Roman" panose="02020603050405020304" charset="0"/>
-              <a:cs typeface="Times New Roman" panose="02020603050405020304" charset="0"/>
-            </a:endParaRPr>
           </a:p>
         </p:txBody>
       </p:sp>
@@ -6678,13 +6439,6 @@
               </a:rPr>
               <a:t>WCAG 2.1 compliance and summary of design outcomes</a:t>
             </a:r>
-            <a:endParaRPr lang="en-US" sz="1600" b="1" dirty="0">
-              <a:solidFill>
-                <a:srgbClr val="8FA3C0"/>
-              </a:solidFill>
-              <a:latin typeface="Times New Roman" panose="02020603050405020304" charset="0"/>
-              <a:cs typeface="Times New Roman" panose="02020603050405020304" charset="0"/>
-            </a:endParaRPr>
           </a:p>
         </p:txBody>
       </p:sp>
@@ -6721,13 +6475,6 @@
               </a:rPr>
               <a:t>♿  Accessibility (WCAG 2.1)</a:t>
             </a:r>
-            <a:endParaRPr lang="en-US" sz="1600" b="1" dirty="0">
-              <a:solidFill>
-                <a:srgbClr val="00C4FF"/>
-              </a:solidFill>
-              <a:latin typeface="Times New Roman" panose="02020603050405020304" charset="0"/>
-              <a:cs typeface="Times New Roman" panose="02020603050405020304" charset="0"/>
-            </a:endParaRPr>
           </a:p>
         </p:txBody>
       </p:sp>
@@ -6789,13 +6536,6 @@
               </a:rPr>
               <a:t>🎨</a:t>
             </a:r>
-            <a:endParaRPr lang="en-US" sz="1600" dirty="0">
-              <a:solidFill>
-                <a:srgbClr val="000000"/>
-              </a:solidFill>
-              <a:latin typeface="Times New Roman" panose="02020603050405020304" charset="0"/>
-              <a:cs typeface="Times New Roman" panose="02020603050405020304" charset="0"/>
-            </a:endParaRPr>
           </a:p>
         </p:txBody>
       </p:sp>
@@ -6832,13 +6572,6 @@
               </a:rPr>
               <a:t>Colour contrast ≥ 4.5:1 (AA standard) for all text</a:t>
             </a:r>
-            <a:endParaRPr lang="en-US" sz="1600" dirty="0">
-              <a:solidFill>
-                <a:srgbClr val="E8EDF5"/>
-              </a:solidFill>
-              <a:latin typeface="Times New Roman" panose="02020603050405020304" charset="0"/>
-              <a:cs typeface="Times New Roman" panose="02020603050405020304" charset="0"/>
-            </a:endParaRPr>
           </a:p>
         </p:txBody>
       </p:sp>
@@ -6900,13 +6633,6 @@
               </a:rPr>
               <a:t>👆</a:t>
             </a:r>
-            <a:endParaRPr lang="en-US" sz="1600" dirty="0">
-              <a:solidFill>
-                <a:srgbClr val="000000"/>
-              </a:solidFill>
-              <a:latin typeface="Times New Roman" panose="02020603050405020304" charset="0"/>
-              <a:cs typeface="Times New Roman" panose="02020603050405020304" charset="0"/>
-            </a:endParaRPr>
           </a:p>
         </p:txBody>
       </p:sp>
@@ -6943,13 +6669,6 @@
               </a:rPr>
               <a:t>Minimum 44×44pt touch targets (Apple HIG &amp; Material Design)</a:t>
             </a:r>
-            <a:endParaRPr lang="en-US" sz="1600" dirty="0">
-              <a:solidFill>
-                <a:srgbClr val="E8EDF5"/>
-              </a:solidFill>
-              <a:latin typeface="Times New Roman" panose="02020603050405020304" charset="0"/>
-              <a:cs typeface="Times New Roman" panose="02020603050405020304" charset="0"/>
-            </a:endParaRPr>
           </a:p>
         </p:txBody>
       </p:sp>
@@ -7011,13 +6730,6 @@
               </a:rPr>
               <a:t>🌙</a:t>
             </a:r>
-            <a:endParaRPr lang="en-US" sz="1600" dirty="0">
-              <a:solidFill>
-                <a:srgbClr val="000000"/>
-              </a:solidFill>
-              <a:latin typeface="Times New Roman" panose="02020603050405020304" charset="0"/>
-              <a:cs typeface="Times New Roman" panose="02020603050405020304" charset="0"/>
-            </a:endParaRPr>
           </a:p>
         </p:txBody>
       </p:sp>
@@ -7054,13 +6766,6 @@
               </a:rPr>
               <a:t>Full dark mode support with maintained contrast ratios</a:t>
             </a:r>
-            <a:endParaRPr lang="en-US" sz="1600" dirty="0">
-              <a:solidFill>
-                <a:srgbClr val="E8EDF5"/>
-              </a:solidFill>
-              <a:latin typeface="Times New Roman" panose="02020603050405020304" charset="0"/>
-              <a:cs typeface="Times New Roman" panose="02020603050405020304" charset="0"/>
-            </a:endParaRPr>
           </a:p>
         </p:txBody>
       </p:sp>
@@ -7122,13 +6827,6 @@
               </a:rPr>
               <a:t>🔤</a:t>
             </a:r>
-            <a:endParaRPr lang="en-US" sz="1600" dirty="0">
-              <a:solidFill>
-                <a:srgbClr val="000000"/>
-              </a:solidFill>
-              <a:latin typeface="Times New Roman" panose="02020603050405020304" charset="0"/>
-              <a:cs typeface="Times New Roman" panose="02020603050405020304" charset="0"/>
-            </a:endParaRPr>
           </a:p>
         </p:txBody>
       </p:sp>
@@ -7165,13 +6863,6 @@
               </a:rPr>
               <a:t>Adjustable text size via device accessibility settings</a:t>
             </a:r>
-            <a:endParaRPr lang="en-US" sz="1600" dirty="0">
-              <a:solidFill>
-                <a:srgbClr val="E8EDF5"/>
-              </a:solidFill>
-              <a:latin typeface="Times New Roman" panose="02020603050405020304" charset="0"/>
-              <a:cs typeface="Times New Roman" panose="02020603050405020304" charset="0"/>
-            </a:endParaRPr>
           </a:p>
         </p:txBody>
       </p:sp>
@@ -7233,13 +6924,6 @@
               </a:rPr>
               <a:t>🔊</a:t>
             </a:r>
-            <a:endParaRPr lang="en-US" sz="1600" dirty="0">
-              <a:solidFill>
-                <a:srgbClr val="000000"/>
-              </a:solidFill>
-              <a:latin typeface="Times New Roman" panose="02020603050405020304" charset="0"/>
-              <a:cs typeface="Times New Roman" panose="02020603050405020304" charset="0"/>
-            </a:endParaRPr>
           </a:p>
         </p:txBody>
       </p:sp>
@@ -7276,13 +6960,6 @@
               </a:rPr>
               <a:t>All images &amp; icons include screen reader labels</a:t>
             </a:r>
-            <a:endParaRPr lang="en-US" sz="1600" dirty="0">
-              <a:solidFill>
-                <a:srgbClr val="E8EDF5"/>
-              </a:solidFill>
-              <a:latin typeface="Times New Roman" panose="02020603050405020304" charset="0"/>
-              <a:cs typeface="Times New Roman" panose="02020603050405020304" charset="0"/>
-            </a:endParaRPr>
           </a:p>
         </p:txBody>
       </p:sp>
@@ -7319,13 +6996,6 @@
               </a:rPr>
               <a:t>📋  Key Design Outcomes</a:t>
             </a:r>
-            <a:endParaRPr lang="en-US" sz="1600" b="1" dirty="0">
-              <a:solidFill>
-                <a:srgbClr val="00C4FF"/>
-              </a:solidFill>
-              <a:latin typeface="Times New Roman" panose="02020603050405020304" charset="0"/>
-              <a:cs typeface="Times New Roman" panose="02020603050405020304" charset="0"/>
-            </a:endParaRPr>
           </a:p>
         </p:txBody>
       </p:sp>
@@ -7406,13 +7076,6 @@
               </a:rPr>
               <a:t>✓  Simplified progressive dashboard reduces cognitive load</a:t>
             </a:r>
-            <a:endParaRPr lang="en-US" sz="1600" dirty="0">
-              <a:solidFill>
-                <a:srgbClr val="E8EDF5"/>
-              </a:solidFill>
-              <a:latin typeface="Times New Roman" panose="02020603050405020304" charset="0"/>
-              <a:cs typeface="Times New Roman" panose="02020603050405020304" charset="0"/>
-            </a:endParaRPr>
           </a:p>
         </p:txBody>
       </p:sp>
@@ -7493,13 +7156,6 @@
               </a:rPr>
               <a:t>✓  5-tab persistent nav — all features within 2 taps</a:t>
             </a:r>
-            <a:endParaRPr lang="en-US" sz="1600" dirty="0">
-              <a:solidFill>
-                <a:srgbClr val="E8EDF5"/>
-              </a:solidFill>
-              <a:latin typeface="Times New Roman" panose="02020603050405020304" charset="0"/>
-              <a:cs typeface="Times New Roman" panose="02020603050405020304" charset="0"/>
-            </a:endParaRPr>
           </a:p>
         </p:txBody>
       </p:sp>
@@ -7580,13 +7236,6 @@
               </a:rPr>
               <a:t>✓  3-step Auto-Trading wizard (down from 6 steps)</a:t>
             </a:r>
-            <a:endParaRPr lang="en-US" sz="1600" dirty="0">
-              <a:solidFill>
-                <a:srgbClr val="E8EDF5"/>
-              </a:solidFill>
-              <a:latin typeface="Times New Roman" panose="02020603050405020304" charset="0"/>
-              <a:cs typeface="Times New Roman" panose="02020603050405020304" charset="0"/>
-            </a:endParaRPr>
           </a:p>
         </p:txBody>
       </p:sp>
@@ -7667,13 +7316,6 @@
               </a:rPr>
               <a:t>✓  Actionable error messages with clear resolutions</a:t>
             </a:r>
-            <a:endParaRPr lang="en-US" sz="1600" dirty="0">
-              <a:solidFill>
-                <a:srgbClr val="E8EDF5"/>
-              </a:solidFill>
-              <a:latin typeface="Times New Roman" panose="02020603050405020304" charset="0"/>
-              <a:cs typeface="Times New Roman" panose="02020603050405020304" charset="0"/>
-            </a:endParaRPr>
           </a:p>
         </p:txBody>
       </p:sp>
@@ -7754,13 +7396,6 @@
               </a:rPr>
               <a:t>✓  Context-aware chatbot with quick-reply chips</a:t>
             </a:r>
-            <a:endParaRPr lang="en-US" sz="1600" dirty="0">
-              <a:solidFill>
-                <a:srgbClr val="E8EDF5"/>
-              </a:solidFill>
-              <a:latin typeface="Times New Roman" panose="02020603050405020304" charset="0"/>
-              <a:cs typeface="Times New Roman" panose="02020603050405020304" charset="0"/>
-            </a:endParaRPr>
           </a:p>
         </p:txBody>
       </p:sp>
@@ -7841,13 +7476,6 @@
               </a:rPr>
               <a:t>✓  First-time onboarding tour for beginner traders</a:t>
             </a:r>
-            <a:endParaRPr lang="en-US" sz="1600" dirty="0">
-              <a:solidFill>
-                <a:srgbClr val="E8EDF5"/>
-              </a:solidFill>
-              <a:latin typeface="Times New Roman" panose="02020603050405020304" charset="0"/>
-              <a:cs typeface="Times New Roman" panose="02020603050405020304" charset="0"/>
-            </a:endParaRPr>
           </a:p>
         </p:txBody>
       </p:sp>
@@ -7877,6 +7505,7 @@
         </p:spPr>
         <p:txBody>
           <a:bodyPr/>
+          <a:lstStyle/>
           <a:p>
             <a:endParaRPr lang="en-US"/>
           </a:p>
@@ -7915,13 +7544,6 @@
               </a:rPr>
               <a:t>Future Work:  Formal usability testing (n=30+)  ·  A/B testing of dashboard variants  ·  Longitudinal studies  ·  AI chatbot with live market data</a:t>
             </a:r>
-            <a:endParaRPr lang="en-US" sz="1600" b="1" dirty="0">
-              <a:solidFill>
-                <a:srgbClr val="8FA3C0"/>
-              </a:solidFill>
-              <a:latin typeface="Times New Roman" panose="02020603050405020304" charset="0"/>
-              <a:cs typeface="Times New Roman" panose="02020603050405020304" charset="0"/>
-            </a:endParaRPr>
           </a:p>
         </p:txBody>
       </p:sp>
@@ -7986,6 +7608,7 @@
         </p:spPr>
         <p:txBody>
           <a:bodyPr/>
+          <a:lstStyle/>
           <a:p>
             <a:pPr marL="0" indent="0" algn="just">
               <a:buNone/>
@@ -8000,6 +7623,41 @@
               </a:rPr>
               <a:t>[1]D. Norman, The Design of Everyday Things, Revised and Expanded Edition. New York, USA: Basic Books, 2013. [Online]. Available: https://www.basicbooks.com/titles/don-norman/the-design-of-everyday-things/9780465050659/</a:t>
             </a:r>
+          </a:p>
+          <a:p>
+            <a:pPr marL="0" indent="0" algn="just">
+              <a:buNone/>
+            </a:pPr>
+            <a:r>
+              <a:rPr lang="en-US" altLang="en-US" sz="1600">
+                <a:solidFill>
+                  <a:schemeClr val="bg1"/>
+                </a:solidFill>
+                <a:latin typeface="Times New Roman" panose="02020603050405020304" charset="0"/>
+                <a:cs typeface="Times New Roman" panose="02020603050405020304" charset="0"/>
+              </a:rPr>
+              <a:t>	</a:t>
+            </a:r>
+          </a:p>
+          <a:p>
+            <a:pPr marL="0" indent="0" algn="just">
+              <a:buNone/>
+            </a:pPr>
+            <a:r>
+              <a:rPr lang="en-US" altLang="en-US" sz="1600">
+                <a:solidFill>
+                  <a:schemeClr val="bg1"/>
+                </a:solidFill>
+                <a:latin typeface="Times New Roman" panose="02020603050405020304" charset="0"/>
+                <a:cs typeface="Times New Roman" panose="02020603050405020304" charset="0"/>
+              </a:rPr>
+              <a:t>[2]J. Nielsen, "Usability 101: Introduction to Usability," Nielsen Norman Group, 2012. [Online]. Available: https://www.nngroup.com/articles/usability-101-introduction-to-usability/</a:t>
+            </a:r>
+          </a:p>
+          <a:p>
+            <a:pPr marL="0" indent="0" algn="just">
+              <a:buNone/>
+            </a:pPr>
             <a:endParaRPr lang="en-US" altLang="en-US" sz="1600">
               <a:solidFill>
                 <a:schemeClr val="bg1"/>
@@ -8020,8 +7678,13 @@
                 <a:latin typeface="Times New Roman" panose="02020603050405020304" charset="0"/>
                 <a:cs typeface="Times New Roman" panose="02020603050405020304" charset="0"/>
               </a:rPr>
-              <a:t>	</a:t>
-            </a:r>
+              <a:t>[3]B. Shneiderman, C. Plaisant, M. Cohen, S. Jacobs, N. Elmqvist and N. Diakopoulos, Designing the User Interface: Strategies for Effective Human-Computer Interaction, 6th ed. Pearson, 2016. https://www.pearson.com/en-us/subject-catalog/p/designing-the-user-interface/P200000003054</a:t>
+            </a:r>
+          </a:p>
+          <a:p>
+            <a:pPr marL="0" indent="0" algn="just">
+              <a:buNone/>
+            </a:pPr>
             <a:endParaRPr lang="en-US" altLang="en-US" sz="1600">
               <a:solidFill>
                 <a:schemeClr val="bg1"/>
@@ -8042,8 +7705,13 @@
                 <a:latin typeface="Times New Roman" panose="02020603050405020304" charset="0"/>
                 <a:cs typeface="Times New Roman" panose="02020603050405020304" charset="0"/>
               </a:rPr>
-              <a:t>[2]J. Nielsen, "Usability 101: Introduction to Usability," Nielsen Norman Group, 2012. [Online]. Available: https://www.nngroup.com/articles/usability-101-introduction-to-usability/</a:t>
-            </a:r>
+              <a:t>[4]A. Dix, J. Finlay, G. Abowd and R. Beale, Human-Computer Interaction, 3rd ed. Pearson Education, 2004. https://www.pearson.com/en-gb/subject-catalog/p/human-computer-interaction/P200000005000</a:t>
+            </a:r>
+          </a:p>
+          <a:p>
+            <a:pPr marL="0" indent="0" algn="just">
+              <a:buNone/>
+            </a:pPr>
             <a:endParaRPr lang="en-US" altLang="en-US" sz="1600">
               <a:solidFill>
                 <a:schemeClr val="bg1"/>
@@ -8056,6 +7724,21 @@
             <a:pPr marL="0" indent="0" algn="just">
               <a:buNone/>
             </a:pPr>
+            <a:r>
+              <a:rPr lang="en-US" altLang="en-US" sz="1600">
+                <a:solidFill>
+                  <a:schemeClr val="bg1"/>
+                </a:solidFill>
+                <a:latin typeface="Times New Roman" panose="02020603050405020304" charset="0"/>
+                <a:cs typeface="Times New Roman" panose="02020603050405020304" charset="0"/>
+              </a:rPr>
+              <a:t>[5]ISO 9241-11, Ergonomics of Human-System Interaction – Usability: Definitions and Concepts, International Organization for Standardization, 2018. [Online]. Available: https://www.iso.org/standard/63500.html</a:t>
+            </a:r>
+          </a:p>
+          <a:p>
+            <a:pPr marL="0" indent="0" algn="just">
+              <a:buNone/>
+            </a:pPr>
             <a:endParaRPr lang="en-US" altLang="en-US" sz="1600">
               <a:solidFill>
                 <a:schemeClr val="bg1"/>
@@ -8076,8 +7759,13 @@
                 <a:latin typeface="Times New Roman" panose="02020603050405020304" charset="0"/>
                 <a:cs typeface="Times New Roman" panose="02020603050405020304" charset="0"/>
               </a:rPr>
-              <a:t>[3]B. Shneiderman, C. Plaisant, M. Cohen, S. Jacobs, N. Elmqvist and N. Diakopoulos, Designing the User Interface: Strategies for Effective Human-Computer Interaction, 6th ed. Pearson, 2016. https://www.pearson.com/en-us/subject-catalog/p/designing-the-user-interface/P200000003054</a:t>
-            </a:r>
+              <a:t>[6]W3C, "Web Content Accessibility Guidelines (WCAG) 2.1," World Wide Web Consortium, 2018. [Online]. Available: https://www.w3.org/TR/WCAG21/</a:t>
+            </a:r>
+          </a:p>
+          <a:p>
+            <a:pPr marL="0" indent="0" algn="just">
+              <a:buNone/>
+            </a:pPr>
             <a:endParaRPr lang="en-US" altLang="en-US" sz="1600">
               <a:solidFill>
                 <a:schemeClr val="bg1"/>
@@ -8090,6 +7778,21 @@
             <a:pPr marL="0" indent="0" algn="just">
               <a:buNone/>
             </a:pPr>
+            <a:r>
+              <a:rPr lang="en-US" altLang="en-US" sz="1600">
+                <a:solidFill>
+                  <a:schemeClr val="bg1"/>
+                </a:solidFill>
+                <a:latin typeface="Times New Roman" panose="02020603050405020304" charset="0"/>
+                <a:cs typeface="Times New Roman" panose="02020603050405020304" charset="0"/>
+              </a:rPr>
+              <a:t>[7]J. Garrett, The Elements of User Experience: User-Centered Design for the Web and Beyond, 2nd ed. New Riders, 2011. https://www.newriders.com/9780321683687</a:t>
+            </a:r>
+          </a:p>
+          <a:p>
+            <a:pPr marL="0" indent="0" algn="just">
+              <a:buNone/>
+            </a:pPr>
             <a:endParaRPr lang="en-US" altLang="en-US" sz="1600">
               <a:solidFill>
                 <a:schemeClr val="bg1"/>
@@ -8102,16 +7805,6 @@
             <a:pPr marL="0" indent="0" algn="just">
               <a:buNone/>
             </a:pPr>
-            <a:r>
-              <a:rPr lang="en-US" altLang="en-US" sz="1600">
-                <a:solidFill>
-                  <a:schemeClr val="bg1"/>
-                </a:solidFill>
-                <a:latin typeface="Times New Roman" panose="02020603050405020304" charset="0"/>
-                <a:cs typeface="Times New Roman" panose="02020603050405020304" charset="0"/>
-              </a:rPr>
-              <a:t>[4]A. Dix, J. Finlay, G. Abowd and R. Beale, Human-Computer Interaction, 3rd ed. Pearson Education, 2004. https://www.pearson.com/en-gb/subject-catalog/p/human-computer-interaction/P200000005000</a:t>
-            </a:r>
             <a:endParaRPr lang="en-US" altLang="en-US" sz="1600">
               <a:solidFill>
                 <a:schemeClr val="bg1"/>
@@ -8120,132 +7813,6 @@
               <a:cs typeface="Times New Roman" panose="02020603050405020304" charset="0"/>
             </a:endParaRPr>
           </a:p>
-          <a:p>
-            <a:pPr marL="0" indent="0" algn="just">
-              <a:buNone/>
-            </a:pPr>
-            <a:endParaRPr lang="en-US" altLang="en-US" sz="1600">
-              <a:solidFill>
-                <a:schemeClr val="bg1"/>
-              </a:solidFill>
-              <a:latin typeface="Times New Roman" panose="02020603050405020304" charset="0"/>
-              <a:cs typeface="Times New Roman" panose="02020603050405020304" charset="0"/>
-            </a:endParaRPr>
-          </a:p>
-          <a:p>
-            <a:pPr marL="0" indent="0" algn="just">
-              <a:buNone/>
-            </a:pPr>
-            <a:r>
-              <a:rPr lang="en-US" altLang="en-US" sz="1600">
-                <a:solidFill>
-                  <a:schemeClr val="bg1"/>
-                </a:solidFill>
-                <a:latin typeface="Times New Roman" panose="02020603050405020304" charset="0"/>
-                <a:cs typeface="Times New Roman" panose="02020603050405020304" charset="0"/>
-              </a:rPr>
-              <a:t>[5]ISO 9241-11, Ergonomics of Human-System Interaction – Usability: Definitions and Concepts, International Organization for Standardization, 2018. [Online]. Available: https://www.iso.org/standard/63500.html</a:t>
-            </a:r>
-            <a:endParaRPr lang="en-US" altLang="en-US" sz="1600">
-              <a:solidFill>
-                <a:schemeClr val="bg1"/>
-              </a:solidFill>
-              <a:latin typeface="Times New Roman" panose="02020603050405020304" charset="0"/>
-              <a:cs typeface="Times New Roman" panose="02020603050405020304" charset="0"/>
-            </a:endParaRPr>
-          </a:p>
-          <a:p>
-            <a:pPr marL="0" indent="0" algn="just">
-              <a:buNone/>
-            </a:pPr>
-            <a:endParaRPr lang="en-US" altLang="en-US" sz="1600">
-              <a:solidFill>
-                <a:schemeClr val="bg1"/>
-              </a:solidFill>
-              <a:latin typeface="Times New Roman" panose="02020603050405020304" charset="0"/>
-              <a:cs typeface="Times New Roman" panose="02020603050405020304" charset="0"/>
-            </a:endParaRPr>
-          </a:p>
-          <a:p>
-            <a:pPr marL="0" indent="0" algn="just">
-              <a:buNone/>
-            </a:pPr>
-            <a:r>
-              <a:rPr lang="en-US" altLang="en-US" sz="1600">
-                <a:solidFill>
-                  <a:schemeClr val="bg1"/>
-                </a:solidFill>
-                <a:latin typeface="Times New Roman" panose="02020603050405020304" charset="0"/>
-                <a:cs typeface="Times New Roman" panose="02020603050405020304" charset="0"/>
-              </a:rPr>
-              <a:t>[6]W3C, "Web Content Accessibility Guidelines (WCAG) 2.1," World Wide Web Consortium, 2018. [Online]. Available: https://www.w3.org/TR/WCAG21/</a:t>
-            </a:r>
-            <a:endParaRPr lang="en-US" altLang="en-US" sz="1600">
-              <a:solidFill>
-                <a:schemeClr val="bg1"/>
-              </a:solidFill>
-              <a:latin typeface="Times New Roman" panose="02020603050405020304" charset="0"/>
-              <a:cs typeface="Times New Roman" panose="02020603050405020304" charset="0"/>
-            </a:endParaRPr>
-          </a:p>
-          <a:p>
-            <a:pPr marL="0" indent="0" algn="just">
-              <a:buNone/>
-            </a:pPr>
-            <a:endParaRPr lang="en-US" altLang="en-US" sz="1600">
-              <a:solidFill>
-                <a:schemeClr val="bg1"/>
-              </a:solidFill>
-              <a:latin typeface="Times New Roman" panose="02020603050405020304" charset="0"/>
-              <a:cs typeface="Times New Roman" panose="02020603050405020304" charset="0"/>
-            </a:endParaRPr>
-          </a:p>
-          <a:p>
-            <a:pPr marL="0" indent="0" algn="just">
-              <a:buNone/>
-            </a:pPr>
-            <a:r>
-              <a:rPr lang="en-US" altLang="en-US" sz="1600">
-                <a:solidFill>
-                  <a:schemeClr val="bg1"/>
-                </a:solidFill>
-                <a:latin typeface="Times New Roman" panose="02020603050405020304" charset="0"/>
-                <a:cs typeface="Times New Roman" panose="02020603050405020304" charset="0"/>
-              </a:rPr>
-              <a:t>[7]J. Garrett, The Elements of User Experience: User-Centered Design for the Web and Beyond, 2nd ed. New Riders, 2011. https://www.newriders.com/9780321683687</a:t>
-            </a:r>
-            <a:endParaRPr lang="en-US" altLang="en-US" sz="1600">
-              <a:solidFill>
-                <a:schemeClr val="bg1"/>
-              </a:solidFill>
-              <a:latin typeface="Times New Roman" panose="02020603050405020304" charset="0"/>
-              <a:cs typeface="Times New Roman" panose="02020603050405020304" charset="0"/>
-            </a:endParaRPr>
-          </a:p>
-          <a:p>
-            <a:pPr marL="0" indent="0" algn="just">
-              <a:buNone/>
-            </a:pPr>
-            <a:endParaRPr lang="en-US" altLang="en-US" sz="1600">
-              <a:solidFill>
-                <a:schemeClr val="bg1"/>
-              </a:solidFill>
-              <a:latin typeface="Times New Roman" panose="02020603050405020304" charset="0"/>
-              <a:cs typeface="Times New Roman" panose="02020603050405020304" charset="0"/>
-            </a:endParaRPr>
-          </a:p>
-          <a:p>
-            <a:pPr marL="0" indent="0" algn="just">
-              <a:buNone/>
-            </a:pPr>
-            <a:endParaRPr lang="en-US" altLang="en-US" sz="1600">
-              <a:solidFill>
-                <a:schemeClr val="bg1"/>
-              </a:solidFill>
-              <a:latin typeface="Times New Roman" panose="02020603050405020304" charset="0"/>
-              <a:cs typeface="Times New Roman" panose="02020603050405020304" charset="0"/>
-            </a:endParaRPr>
-          </a:p>
         </p:txBody>
       </p:sp>
       <p:sp>
@@ -8281,13 +7848,6 @@
               </a:rPr>
               <a:t>References</a:t>
             </a:r>
-            <a:endParaRPr lang="en-US" sz="2800" b="1" dirty="0">
-              <a:solidFill>
-                <a:srgbClr val="FFFFFF"/>
-              </a:solidFill>
-              <a:latin typeface="Times New Roman" panose="02020603050405020304" charset="0"/>
-              <a:cs typeface="Times New Roman" panose="02020603050405020304" charset="0"/>
-            </a:endParaRPr>
           </a:p>
         </p:txBody>
       </p:sp>
@@ -8352,6 +7912,7 @@
         </p:spPr>
         <p:txBody>
           <a:bodyPr/>
+          <a:lstStyle/>
           <a:p>
             <a:pPr marL="0" indent="0" algn="ctr">
               <a:buNone/>
@@ -8402,13 +7963,6 @@
               </a:rPr>
               <a:t>Thank You</a:t>
             </a:r>
-            <a:endParaRPr lang="en-US" altLang="en-US" sz="4400">
-              <a:solidFill>
-                <a:schemeClr val="bg1"/>
-              </a:solidFill>
-              <a:latin typeface="Times New Roman" panose="02020603050405020304" charset="0"/>
-              <a:cs typeface="Times New Roman" panose="02020603050405020304" charset="0"/>
-            </a:endParaRPr>
           </a:p>
         </p:txBody>
       </p:sp>
@@ -8513,6 +8067,7 @@
         </p:spPr>
         <p:txBody>
           <a:bodyPr/>
+          <a:lstStyle/>
           <a:p>
             <a:endParaRPr lang="en-US"/>
           </a:p>
@@ -8686,13 +8241,6 @@
               </a:rPr>
               <a:t>AI-powered chatbot for real-time support</a:t>
             </a:r>
-            <a:endParaRPr lang="en-US" sz="1600" dirty="0">
-              <a:solidFill>
-                <a:srgbClr val="E8EDF5"/>
-              </a:solidFill>
-              <a:latin typeface="Times New Roman" panose="02020603050405020304" charset="0"/>
-              <a:cs typeface="Times New Roman" panose="02020603050405020304" charset="0"/>
-            </a:endParaRPr>
           </a:p>
           <a:p>
             <a:pPr marL="0" indent="0">
@@ -8793,6 +8341,7 @@
         </p:spPr>
         <p:txBody>
           <a:bodyPr/>
+          <a:lstStyle/>
           <a:p>
             <a:r>
               <a:rPr lang="en-US" b="1" dirty="0">
@@ -8803,12 +8352,6 @@
               </a:rPr>
               <a:t>Target Users</a:t>
             </a:r>
-            <a:endParaRPr lang="en-US" b="1" dirty="0">
-              <a:solidFill>
-                <a:srgbClr val="00C4FF"/>
-              </a:solidFill>
-              <a:sym typeface="+mn-ea"/>
-            </a:endParaRPr>
           </a:p>
           <a:p>
             <a:endParaRPr lang="en-US" dirty="0"/>
@@ -9264,13 +8807,6 @@
               </a:rPr>
               <a:t>Key Usability Issues from AT2</a:t>
             </a:r>
-            <a:endParaRPr lang="en-US" altLang="en-US" sz="2800" b="1" dirty="0">
-              <a:solidFill>
-                <a:schemeClr val="bg1"/>
-              </a:solidFill>
-              <a:latin typeface="Times New Roman" panose="02020603050405020304" charset="0"/>
-              <a:cs typeface="Times New Roman" panose="02020603050405020304" charset="0"/>
-            </a:endParaRPr>
           </a:p>
           <a:p>
             <a:pPr marL="0" indent="0">
@@ -9312,6 +8848,7 @@
         </p:spPr>
         <p:txBody>
           <a:bodyPr/>
+          <a:lstStyle/>
           <a:p>
             <a:endParaRPr lang="en-US"/>
           </a:p>
@@ -9402,6 +8939,7 @@
         </p:spPr>
         <p:txBody>
           <a:bodyPr/>
+          <a:lstStyle/>
           <a:p>
             <a:endParaRPr lang="en-US" sz="1600">
               <a:latin typeface="Times New Roman" panose="02020603050405020304" charset="0"/>
@@ -9443,13 +8981,6 @@
               </a:rPr>
               <a:t>HIGH</a:t>
             </a:r>
-            <a:endParaRPr lang="en-US" sz="1600" b="1" dirty="0">
-              <a:solidFill>
-                <a:srgbClr val="0A0E1A"/>
-              </a:solidFill>
-              <a:latin typeface="Times New Roman" panose="02020603050405020304" charset="0"/>
-              <a:cs typeface="Times New Roman" panose="02020603050405020304" charset="0"/>
-            </a:endParaRPr>
           </a:p>
         </p:txBody>
       </p:sp>
@@ -9486,13 +9017,6 @@
               </a:rPr>
               <a:t>Complex Navigation</a:t>
             </a:r>
-            <a:endParaRPr lang="en-US" sz="1600" b="1" dirty="0">
-              <a:solidFill>
-                <a:srgbClr val="FFFFFF"/>
-              </a:solidFill>
-              <a:latin typeface="Times New Roman" panose="02020603050405020304" charset="0"/>
-              <a:cs typeface="Times New Roman" panose="02020603050405020304" charset="0"/>
-            </a:endParaRPr>
           </a:p>
         </p:txBody>
       </p:sp>
@@ -9529,13 +9053,6 @@
               </a:rPr>
               <a:t>Users struggled to locate Auto-Trading &amp; key features</a:t>
             </a:r>
-            <a:endParaRPr lang="en-US" sz="1600" dirty="0">
-              <a:solidFill>
-                <a:srgbClr val="8FA3C0"/>
-              </a:solidFill>
-              <a:latin typeface="Times New Roman" panose="02020603050405020304" charset="0"/>
-              <a:cs typeface="Times New Roman" panose="02020603050405020304" charset="0"/>
-            </a:endParaRPr>
           </a:p>
         </p:txBody>
       </p:sp>
@@ -9616,13 +9133,6 @@
               </a:rPr>
               <a:t>HIGH</a:t>
             </a:r>
-            <a:endParaRPr lang="en-US" sz="1600" b="1" dirty="0">
-              <a:solidFill>
-                <a:srgbClr val="0A0E1A"/>
-              </a:solidFill>
-              <a:latin typeface="Times New Roman" panose="02020603050405020304" charset="0"/>
-              <a:cs typeface="Times New Roman" panose="02020603050405020304" charset="0"/>
-            </a:endParaRPr>
           </a:p>
         </p:txBody>
       </p:sp>
@@ -9659,13 +9169,6 @@
               </a:rPr>
               <a:t>Inconsistent Button Placement</a:t>
             </a:r>
-            <a:endParaRPr lang="en-US" sz="1600" b="1" dirty="0">
-              <a:solidFill>
-                <a:srgbClr val="FFFFFF"/>
-              </a:solidFill>
-              <a:latin typeface="Times New Roman" panose="02020603050405020304" charset="0"/>
-              <a:cs typeface="Times New Roman" panose="02020603050405020304" charset="0"/>
-            </a:endParaRPr>
           </a:p>
         </p:txBody>
       </p:sp>
@@ -9702,13 +9205,6 @@
               </a:rPr>
               <a:t>Buy/Sell buttons appeared in different positions</a:t>
             </a:r>
-            <a:endParaRPr lang="en-US" sz="1600" dirty="0">
-              <a:solidFill>
-                <a:srgbClr val="8FA3C0"/>
-              </a:solidFill>
-              <a:latin typeface="Times New Roman" panose="02020603050405020304" charset="0"/>
-              <a:cs typeface="Times New Roman" panose="02020603050405020304" charset="0"/>
-            </a:endParaRPr>
           </a:p>
         </p:txBody>
       </p:sp>
@@ -9789,13 +9285,6 @@
               </a:rPr>
               <a:t>HIGH</a:t>
             </a:r>
-            <a:endParaRPr lang="en-US" sz="1600" b="1" dirty="0">
-              <a:solidFill>
-                <a:srgbClr val="0A0E1A"/>
-              </a:solidFill>
-              <a:latin typeface="Times New Roman" panose="02020603050405020304" charset="0"/>
-              <a:cs typeface="Times New Roman" panose="02020603050405020304" charset="0"/>
-            </a:endParaRPr>
           </a:p>
         </p:txBody>
       </p:sp>
@@ -9832,13 +9321,6 @@
               </a:rPr>
               <a:t>Information Overload on Dashboard</a:t>
             </a:r>
-            <a:endParaRPr lang="en-US" sz="1600" b="1" dirty="0">
-              <a:solidFill>
-                <a:srgbClr val="FFFFFF"/>
-              </a:solidFill>
-              <a:latin typeface="Times New Roman" panose="02020603050405020304" charset="0"/>
-              <a:cs typeface="Times New Roman" panose="02020603050405020304" charset="0"/>
-            </a:endParaRPr>
           </a:p>
         </p:txBody>
       </p:sp>
@@ -9875,13 +9357,6 @@
               </a:rPr>
               <a:t>Excessive charts caused confusion &amp; slow decisions</a:t>
             </a:r>
-            <a:endParaRPr lang="en-US" sz="1600" dirty="0">
-              <a:solidFill>
-                <a:srgbClr val="8FA3C0"/>
-              </a:solidFill>
-              <a:latin typeface="Times New Roman" panose="02020603050405020304" charset="0"/>
-              <a:cs typeface="Times New Roman" panose="02020603050405020304" charset="0"/>
-            </a:endParaRPr>
           </a:p>
         </p:txBody>
       </p:sp>
@@ -9962,13 +9437,6 @@
               </a:rPr>
               <a:t>MED</a:t>
             </a:r>
-            <a:endParaRPr lang="en-US" sz="1600" b="1" dirty="0">
-              <a:solidFill>
-                <a:srgbClr val="0A0E1A"/>
-              </a:solidFill>
-              <a:latin typeface="Times New Roman" panose="02020603050405020304" charset="0"/>
-              <a:cs typeface="Times New Roman" panose="02020603050405020304" charset="0"/>
-            </a:endParaRPr>
           </a:p>
         </p:txBody>
       </p:sp>
@@ -10005,13 +9473,6 @@
               </a:rPr>
               <a:t>Insufficient Error Feedback</a:t>
             </a:r>
-            <a:endParaRPr lang="en-US" sz="1600" b="1" dirty="0">
-              <a:solidFill>
-                <a:srgbClr val="FFFFFF"/>
-              </a:solidFill>
-              <a:latin typeface="Times New Roman" panose="02020603050405020304" charset="0"/>
-              <a:cs typeface="Times New Roman" panose="02020603050405020304" charset="0"/>
-            </a:endParaRPr>
           </a:p>
         </p:txBody>
       </p:sp>
@@ -10048,13 +9509,6 @@
               </a:rPr>
               <a:t>Unclear messages during fund transfers frustrated users</a:t>
             </a:r>
-            <a:endParaRPr lang="en-US" sz="1600" dirty="0">
-              <a:solidFill>
-                <a:srgbClr val="8FA3C0"/>
-              </a:solidFill>
-              <a:latin typeface="Times New Roman" panose="02020603050405020304" charset="0"/>
-              <a:cs typeface="Times New Roman" panose="02020603050405020304" charset="0"/>
-            </a:endParaRPr>
           </a:p>
         </p:txBody>
       </p:sp>
@@ -10135,13 +9589,6 @@
               </a:rPr>
               <a:t>MED</a:t>
             </a:r>
-            <a:endParaRPr lang="en-US" sz="1600" b="1" dirty="0">
-              <a:solidFill>
-                <a:srgbClr val="0A0E1A"/>
-              </a:solidFill>
-              <a:latin typeface="Times New Roman" panose="02020603050405020304" charset="0"/>
-              <a:cs typeface="Times New Roman" panose="02020603050405020304" charset="0"/>
-            </a:endParaRPr>
           </a:p>
         </p:txBody>
       </p:sp>
@@ -10178,13 +9625,6 @@
               </a:rPr>
               <a:t>Chatbot Limitations</a:t>
             </a:r>
-            <a:endParaRPr lang="en-US" sz="1600" b="1" dirty="0">
-              <a:solidFill>
-                <a:srgbClr val="FFFFFF"/>
-              </a:solidFill>
-              <a:latin typeface="Times New Roman" panose="02020603050405020304" charset="0"/>
-              <a:cs typeface="Times New Roman" panose="02020603050405020304" charset="0"/>
-            </a:endParaRPr>
           </a:p>
         </p:txBody>
       </p:sp>
@@ -10221,13 +9661,6 @@
               </a:rPr>
               <a:t>Repetitive, uninformative responses reduced trust</a:t>
             </a:r>
-            <a:endParaRPr lang="en-US" sz="1600" dirty="0">
-              <a:solidFill>
-                <a:srgbClr val="8FA3C0"/>
-              </a:solidFill>
-              <a:latin typeface="Times New Roman" panose="02020603050405020304" charset="0"/>
-              <a:cs typeface="Times New Roman" panose="02020603050405020304" charset="0"/>
-            </a:endParaRPr>
           </a:p>
         </p:txBody>
       </p:sp>
@@ -10308,13 +9741,6 @@
               </a:rPr>
               <a:t>MED</a:t>
             </a:r>
-            <a:endParaRPr lang="en-US" sz="1600" b="1" dirty="0">
-              <a:solidFill>
-                <a:srgbClr val="0A0E1A"/>
-              </a:solidFill>
-              <a:latin typeface="Times New Roman" panose="02020603050405020304" charset="0"/>
-              <a:cs typeface="Times New Roman" panose="02020603050405020304" charset="0"/>
-            </a:endParaRPr>
           </a:p>
         </p:txBody>
       </p:sp>
@@ -10351,13 +9777,6 @@
               </a:rPr>
               <a:t>No Beginner Onboarding</a:t>
             </a:r>
-            <a:endParaRPr lang="en-US" sz="1600" b="1" dirty="0">
-              <a:solidFill>
-                <a:srgbClr val="FFFFFF"/>
-              </a:solidFill>
-              <a:latin typeface="Times New Roman" panose="02020603050405020304" charset="0"/>
-              <a:cs typeface="Times New Roman" panose="02020603050405020304" charset="0"/>
-            </a:endParaRPr>
           </a:p>
         </p:txBody>
       </p:sp>
@@ -10394,13 +9813,6 @@
               </a:rPr>
               <a:t>New users couldn't understand terminology or flows</a:t>
             </a:r>
-            <a:endParaRPr lang="en-US" sz="1600" dirty="0">
-              <a:solidFill>
-                <a:srgbClr val="8FA3C0"/>
-              </a:solidFill>
-              <a:latin typeface="Times New Roman" panose="02020603050405020304" charset="0"/>
-              <a:cs typeface="Times New Roman" panose="02020603050405020304" charset="0"/>
-            </a:endParaRPr>
           </a:p>
         </p:txBody>
       </p:sp>
@@ -10465,6 +9877,7 @@
         </p:spPr>
         <p:txBody>
           <a:bodyPr/>
+          <a:lstStyle/>
           <a:p>
             <a:pPr marL="0" indent="0" algn="ctr">
               <a:buNone/>
@@ -10583,7 +9996,7 @@
           <p:nvPr/>
         </p:nvPicPr>
         <p:blipFill>
-          <a:blip r:embed="rId1"/>
+          <a:blip r:embed="rId2"/>
           <a:stretch>
             <a:fillRect/>
           </a:stretch>
@@ -10658,13 +10071,6 @@
               </a:rPr>
               <a:t>Theoretical Framework</a:t>
             </a:r>
-            <a:endParaRPr lang="en-US" sz="2000" b="1" dirty="0">
-              <a:solidFill>
-                <a:srgbClr val="00C4FF"/>
-              </a:solidFill>
-              <a:latin typeface="Times New Roman" panose="02020603050405020304" charset="0"/>
-              <a:cs typeface="Times New Roman" panose="02020603050405020304" charset="0"/>
-            </a:endParaRPr>
           </a:p>
           <a:p>
             <a:pPr marL="0" indent="0">
@@ -10824,13 +10230,6 @@
               </a:rPr>
               <a:t>Key Design Decisions</a:t>
             </a:r>
-            <a:endParaRPr lang="en-US" altLang="en-US" sz="2800" b="1" dirty="0">
-              <a:solidFill>
-                <a:schemeClr val="bg1"/>
-              </a:solidFill>
-              <a:latin typeface="Times New Roman" panose="02020603050405020304" charset="0"/>
-              <a:cs typeface="Times New Roman" panose="02020603050405020304" charset="0"/>
-            </a:endParaRPr>
           </a:p>
           <a:p>
             <a:pPr marL="0" indent="0">
@@ -10872,6 +10271,7 @@
         </p:spPr>
         <p:txBody>
           <a:bodyPr/>
+          <a:lstStyle/>
           <a:p>
             <a:endParaRPr lang="en-US"/>
           </a:p>
@@ -10913,6 +10313,11 @@
               </a:rPr>
               <a:t>Evidence-based decisions to address AT2 usability findings</a:t>
             </a:r>
+          </a:p>
+          <a:p>
+            <a:pPr marL="0" indent="0">
+              <a:buNone/>
+            </a:pPr>
             <a:endParaRPr lang="en-US" altLang="en-US" b="1" dirty="0">
               <a:solidFill>
                 <a:schemeClr val="accent5">
@@ -10924,21 +10329,6 @@
               <a:cs typeface="Times New Roman" panose="02020603050405020304" charset="0"/>
             </a:endParaRPr>
           </a:p>
-          <a:p>
-            <a:pPr marL="0" indent="0">
-              <a:buNone/>
-            </a:pPr>
-            <a:endParaRPr lang="en-US" altLang="en-US" b="1" dirty="0">
-              <a:solidFill>
-                <a:schemeClr val="accent5">
-                  <a:lumMod val="60000"/>
-                  <a:lumOff val="40000"/>
-                </a:schemeClr>
-              </a:solidFill>
-              <a:latin typeface="Times New Roman" panose="02020603050405020304" charset="0"/>
-              <a:cs typeface="Times New Roman" panose="02020603050405020304" charset="0"/>
-            </a:endParaRPr>
-          </a:p>
         </p:txBody>
       </p:sp>
       <p:sp>
@@ -11030,13 +10420,6 @@
               </a:rPr>
               <a:t>Simplified Dashboard</a:t>
             </a:r>
-            <a:endParaRPr lang="en-US" b="1" dirty="0">
-              <a:solidFill>
-                <a:srgbClr val="FFFFFF"/>
-              </a:solidFill>
-              <a:latin typeface="Times New Roman" panose="02020603050405020304" charset="0"/>
-              <a:cs typeface="Times New Roman" panose="02020603050405020304" charset="0"/>
-            </a:endParaRPr>
           </a:p>
         </p:txBody>
       </p:sp>
@@ -11077,13 +10460,6 @@
               </a:rPr>
               <a:t>Progressive disclosure — only balance, recent activity &amp; quick-actions shown initially. Addresses cognitive overload (3/5 score).</a:t>
             </a:r>
-            <a:endParaRPr lang="en-US" sz="1600" dirty="0">
-              <a:solidFill>
-                <a:srgbClr val="8FA3C0"/>
-              </a:solidFill>
-              <a:latin typeface="Times New Roman" panose="02020603050405020304" charset="0"/>
-              <a:cs typeface="Times New Roman" panose="02020603050405020304" charset="0"/>
-            </a:endParaRPr>
           </a:p>
         </p:txBody>
       </p:sp>
@@ -11176,13 +10552,6 @@
               </a:rPr>
               <a:t>Consistent Navigation</a:t>
             </a:r>
-            <a:endParaRPr lang="en-US" b="1" dirty="0">
-              <a:solidFill>
-                <a:srgbClr val="FFFFFF"/>
-              </a:solidFill>
-              <a:latin typeface="Times New Roman" panose="02020603050405020304" charset="0"/>
-              <a:cs typeface="Times New Roman" panose="02020603050405020304" charset="0"/>
-            </a:endParaRPr>
           </a:p>
         </p:txBody>
       </p:sp>
@@ -11223,13 +10592,6 @@
               </a:rPr>
               <a:t>Persistent 5-tab bottom nav (Home, Markets, Portfolio, Alerts, Settings). All features within 2 taps.</a:t>
             </a:r>
-            <a:endParaRPr lang="en-US" sz="1600" dirty="0">
-              <a:solidFill>
-                <a:srgbClr val="8FA3C0"/>
-              </a:solidFill>
-              <a:latin typeface="Times New Roman" panose="02020603050405020304" charset="0"/>
-              <a:cs typeface="Times New Roman" panose="02020603050405020304" charset="0"/>
-            </a:endParaRPr>
           </a:p>
         </p:txBody>
       </p:sp>
@@ -11322,13 +10684,6 @@
               </a:rPr>
               <a:t>Guided Auto-Trading Wizard</a:t>
             </a:r>
-            <a:endParaRPr lang="en-US" b="1" dirty="0">
-              <a:solidFill>
-                <a:srgbClr val="FFFFFF"/>
-              </a:solidFill>
-              <a:latin typeface="Times New Roman" panose="02020603050405020304" charset="0"/>
-              <a:cs typeface="Times New Roman" panose="02020603050405020304" charset="0"/>
-            </a:endParaRPr>
           </a:p>
         </p:txBody>
       </p:sp>
@@ -11369,13 +10724,6 @@
               </a:rPr>
               <a:t>3-step wizard with DCA, Momentum &amp; Stop-Loss templates. Reduced from 3 min 20 sec to projected 1 min 50 sec.</a:t>
             </a:r>
-            <a:endParaRPr lang="en-US" sz="1600" dirty="0">
-              <a:solidFill>
-                <a:srgbClr val="8FA3C0"/>
-              </a:solidFill>
-              <a:latin typeface="Times New Roman" panose="02020603050405020304" charset="0"/>
-              <a:cs typeface="Times New Roman" panose="02020603050405020304" charset="0"/>
-            </a:endParaRPr>
           </a:p>
         </p:txBody>
       </p:sp>
@@ -11468,13 +10816,6 @@
               </a:rPr>
               <a:t>Improved Error Handling</a:t>
             </a:r>
-            <a:endParaRPr lang="en-US" b="1" dirty="0">
-              <a:solidFill>
-                <a:srgbClr val="FFFFFF"/>
-              </a:solidFill>
-              <a:latin typeface="Times New Roman" panose="02020603050405020304" charset="0"/>
-              <a:cs typeface="Times New Roman" panose="02020603050405020304" charset="0"/>
-            </a:endParaRPr>
           </a:p>
         </p:txBody>
       </p:sp>
@@ -11515,13 +10856,6 @@
               </a:rPr>
               <a:t>All errors include: what went wrong, likely cause, suggested fix. Confirmation screen before any funds are moved.</a:t>
             </a:r>
-            <a:endParaRPr lang="en-US" sz="1600" dirty="0">
-              <a:solidFill>
-                <a:srgbClr val="8FA3C0"/>
-              </a:solidFill>
-              <a:latin typeface="Times New Roman" panose="02020603050405020304" charset="0"/>
-              <a:cs typeface="Times New Roman" panose="02020603050405020304" charset="0"/>
-            </a:endParaRPr>
           </a:p>
         </p:txBody>
       </p:sp>
@@ -11614,13 +10948,6 @@
               </a:rPr>
               <a:t>Enhanced Chatbot</a:t>
             </a:r>
-            <a:endParaRPr lang="en-US" b="1" dirty="0">
-              <a:solidFill>
-                <a:srgbClr val="FFFFFF"/>
-              </a:solidFill>
-              <a:latin typeface="Times New Roman" panose="02020603050405020304" charset="0"/>
-              <a:cs typeface="Times New Roman" panose="02020603050405020304" charset="0"/>
-            </a:endParaRPr>
           </a:p>
         </p:txBody>
       </p:sp>
@@ -11661,13 +10988,6 @@
               </a:rPr>
               <a:t>Context-aware — detects current screen. Quick-reply chips. Human-agent escalation button. Rated 3.6/5 → target 4.3/5.</a:t>
             </a:r>
-            <a:endParaRPr lang="en-US" sz="1600" dirty="0">
-              <a:solidFill>
-                <a:srgbClr val="8FA3C0"/>
-              </a:solidFill>
-              <a:latin typeface="Times New Roman" panose="02020603050405020304" charset="0"/>
-              <a:cs typeface="Times New Roman" panose="02020603050405020304" charset="0"/>
-            </a:endParaRPr>
           </a:p>
         </p:txBody>
       </p:sp>
@@ -11760,13 +11080,6 @@
               </a:rPr>
               <a:t>Onboarding Tour</a:t>
             </a:r>
-            <a:endParaRPr lang="en-US" b="1" dirty="0">
-              <a:solidFill>
-                <a:srgbClr val="FFFFFF"/>
-              </a:solidFill>
-              <a:latin typeface="Times New Roman" panose="02020603050405020304" charset="0"/>
-              <a:cs typeface="Times New Roman" panose="02020603050405020304" charset="0"/>
-            </a:endParaRPr>
           </a:p>
         </p:txBody>
       </p:sp>
@@ -11807,13 +11120,6 @@
               </a:rPr>
               <a:t>Interactive first-time walkthrough with tooltips for key features and trading concepts. Critical for beginner traders.</a:t>
             </a:r>
-            <a:endParaRPr lang="en-US" dirty="0">
-              <a:solidFill>
-                <a:srgbClr val="8FA3C0"/>
-              </a:solidFill>
-              <a:latin typeface="Times New Roman" panose="02020603050405020304" charset="0"/>
-              <a:cs typeface="Times New Roman" panose="02020603050405020304" charset="0"/>
-            </a:endParaRPr>
           </a:p>
         </p:txBody>
       </p:sp>
@@ -11878,6 +11184,7 @@
         </p:spPr>
         <p:txBody>
           <a:bodyPr/>
+          <a:lstStyle/>
           <a:p>
             <a:pPr marL="0" indent="0" algn="ctr">
               <a:buNone/>
@@ -11909,6 +11216,7 @@
           <a:bodyPr wrap="square" rtlCol="0" anchor="t">
             <a:spAutoFit/>
           </a:bodyPr>
+          <a:lstStyle/>
           <a:p>
             <a:r>
               <a:rPr lang="en-US" altLang="en-US" sz="2800" b="1">
@@ -11920,13 +11228,6 @@
               </a:rPr>
               <a:t>Design System </a:t>
             </a:r>
-            <a:endParaRPr lang="en-US" altLang="en-US" sz="2800" b="1">
-              <a:solidFill>
-                <a:schemeClr val="bg1"/>
-              </a:solidFill>
-              <a:latin typeface="Times New Roman" panose="02020603050405020304" charset="0"/>
-              <a:cs typeface="Times New Roman" panose="02020603050405020304" charset="0"/>
-            </a:endParaRPr>
           </a:p>
         </p:txBody>
       </p:sp>
@@ -11979,7 +11280,7 @@
           <p:nvPr/>
         </p:nvPicPr>
         <p:blipFill>
-          <a:blip r:embed="rId1"/>
+          <a:blip r:embed="rId2"/>
           <a:stretch>
             <a:fillRect/>
           </a:stretch>
@@ -12055,6 +11356,7 @@
         </p:spPr>
         <p:txBody>
           <a:bodyPr/>
+          <a:lstStyle/>
           <a:p>
             <a:pPr marL="0" indent="0">
               <a:buNone/>
@@ -12097,6 +11399,7 @@
           <a:bodyPr wrap="square" rtlCol="0" anchor="t">
             <a:spAutoFit/>
           </a:bodyPr>
+          <a:lstStyle/>
           <a:p>
             <a:r>
               <a:rPr lang="en-US" altLang="en-US" sz="2800" b="1">
@@ -12108,13 +11411,6 @@
               </a:rPr>
               <a:t>Visuals</a:t>
             </a:r>
-            <a:endParaRPr lang="en-US" altLang="en-US" sz="2800" b="1">
-              <a:solidFill>
-                <a:schemeClr val="bg1"/>
-              </a:solidFill>
-              <a:latin typeface="Times New Roman" panose="02020603050405020304" charset="0"/>
-              <a:cs typeface="Times New Roman" panose="02020603050405020304" charset="0"/>
-            </a:endParaRPr>
           </a:p>
         </p:txBody>
       </p:sp>
@@ -12139,15 +11435,40 @@
                 <a:tableStyleId>{5C22544A-7EE6-4342-B048-85BDC9FD1C3A}</a:tableStyleId>
               </a:tblPr>
               <a:tblGrid>
-                <a:gridCol w="2685415"/>
-                <a:gridCol w="2685415"/>
-                <a:gridCol w="2685415"/>
-                <a:gridCol w="2685415"/>
+                <a:gridCol w="2685415">
+                  <a:extLst>
+                    <a:ext uri="{9D8B030D-6E8A-4147-A177-3AD203B41FA5}">
+                      <a16:colId xmlns:a16="http://schemas.microsoft.com/office/drawing/2014/main" val="20000"/>
+                    </a:ext>
+                  </a:extLst>
+                </a:gridCol>
+                <a:gridCol w="2685415">
+                  <a:extLst>
+                    <a:ext uri="{9D8B030D-6E8A-4147-A177-3AD203B41FA5}">
+                      <a16:colId xmlns:a16="http://schemas.microsoft.com/office/drawing/2014/main" val="20001"/>
+                    </a:ext>
+                  </a:extLst>
+                </a:gridCol>
+                <a:gridCol w="2685415">
+                  <a:extLst>
+                    <a:ext uri="{9D8B030D-6E8A-4147-A177-3AD203B41FA5}">
+                      <a16:colId xmlns:a16="http://schemas.microsoft.com/office/drawing/2014/main" val="20002"/>
+                    </a:ext>
+                  </a:extLst>
+                </a:gridCol>
+                <a:gridCol w="2685415">
+                  <a:extLst>
+                    <a:ext uri="{9D8B030D-6E8A-4147-A177-3AD203B41FA5}">
+                      <a16:colId xmlns:a16="http://schemas.microsoft.com/office/drawing/2014/main" val="20003"/>
+                    </a:ext>
+                  </a:extLst>
+                </a:gridCol>
               </a:tblGrid>
               <a:tr h="2459990">
                 <a:tc>
                   <a:txBody>
                     <a:bodyPr/>
+                    <a:lstStyle/>
                     <a:p>
                       <a:pPr>
                         <a:buNone/>
@@ -12207,10 +11528,6 @@
                         </a:rPr>
                         <a:t>Figure 1. Login Screen – Trading Mobile Application </a:t>
                       </a:r>
-                      <a:endParaRPr lang="en-US" altLang="en-US" sz="1200">
-                        <a:latin typeface="Times New Roman" panose="02020603050405020304" charset="0"/>
-                        <a:cs typeface="Times New Roman" panose="02020603050405020304" charset="0"/>
-                      </a:endParaRPr>
                     </a:p>
                   </a:txBody>
                   <a:tcPr>
@@ -12238,6 +11555,7 @@
                 <a:tc>
                   <a:txBody>
                     <a:bodyPr/>
+                    <a:lstStyle/>
                     <a:p>
                       <a:pPr>
                         <a:buNone/>
@@ -12301,7 +11619,6 @@
                         <a:rPr lang="en-US" altLang="en-US"/>
                         <a:t> </a:t>
                       </a:r>
-                      <a:endParaRPr lang="en-US" altLang="en-US"/>
                     </a:p>
                   </a:txBody>
                   <a:tcPr>
@@ -12329,6 +11646,7 @@
                 <a:tc>
                   <a:txBody>
                     <a:bodyPr/>
+                    <a:lstStyle/>
                     <a:p>
                       <a:pPr>
                         <a:buNone/>
@@ -12385,7 +11703,6 @@
                         <a:rPr lang="en-US" altLang="en-US" sz="1200"/>
                         <a:t>Figure 3. Markets Screen showing Crypto and Stocks views</a:t>
                       </a:r>
-                      <a:endParaRPr lang="en-US" altLang="en-US" sz="1200"/>
                     </a:p>
                   </a:txBody>
                   <a:tcPr>
@@ -12413,6 +11730,7 @@
                 <a:tc>
                   <a:txBody>
                     <a:bodyPr/>
+                    <a:lstStyle/>
                     <a:p>
                       <a:pPr>
                         <a:buNone/>
@@ -12472,10 +11790,6 @@
                         </a:rPr>
                         <a:t>Figure 4. Transaction (Buy/Sell) Screen with Review Order flow </a:t>
                       </a:r>
-                      <a:endParaRPr lang="en-US" altLang="en-US" sz="1200" b="1">
-                        <a:latin typeface="Times New Roman" panose="02020603050405020304" charset="0"/>
-                        <a:cs typeface="Times New Roman" panose="02020603050405020304" charset="0"/>
-                      </a:endParaRPr>
                     </a:p>
                   </a:txBody>
                   <a:tcPr>
@@ -12500,11 +11814,17 @@
                     </a:gradFill>
                   </a:tcPr>
                 </a:tc>
+                <a:extLst>
+                  <a:ext uri="{0D108BD9-81ED-4DB2-BD59-A6C34878D82A}">
+                    <a16:rowId xmlns:a16="http://schemas.microsoft.com/office/drawing/2014/main" val="10000"/>
+                  </a:ext>
+                </a:extLst>
               </a:tr>
               <a:tr h="2459990">
                 <a:tc>
                   <a:txBody>
                     <a:bodyPr/>
+                    <a:lstStyle/>
                     <a:p>
                       <a:pPr>
                         <a:buNone/>
@@ -12591,13 +11911,6 @@
                         </a:rPr>
                         <a:t>Figure 5. Auto-Trading Wizard – Step 1: Strategy Templates</a:t>
                       </a:r>
-                      <a:endParaRPr lang="en-US" altLang="en-US" sz="1200" b="1">
-                        <a:solidFill>
-                          <a:schemeClr val="bg1"/>
-                        </a:solidFill>
-                        <a:latin typeface="Times New Roman" panose="02020603050405020304" charset="0"/>
-                        <a:cs typeface="Times New Roman" panose="02020603050405020304" charset="0"/>
-                      </a:endParaRPr>
                     </a:p>
                   </a:txBody>
                   <a:tcPr>
@@ -12625,6 +11938,7 @@
                 <a:tc>
                   <a:txBody>
                     <a:bodyPr/>
+                    <a:lstStyle/>
                     <a:p>
                       <a:pPr>
                         <a:buNone/>
@@ -12711,13 +12025,6 @@
                         </a:rPr>
                         <a:t>Figure 6. Auto-Trading Wizard – Step 2: Set Rules</a:t>
                       </a:r>
-                      <a:endParaRPr lang="en-US" altLang="en-US" sz="1200" b="1">
-                        <a:solidFill>
-                          <a:schemeClr val="bg1"/>
-                        </a:solidFill>
-                        <a:latin typeface="Times New Roman" panose="02020603050405020304" charset="0"/>
-                        <a:cs typeface="Times New Roman" panose="02020603050405020304" charset="0"/>
-                      </a:endParaRPr>
                     </a:p>
                   </a:txBody>
                   <a:tcPr>
@@ -12745,6 +12052,7 @@
                 <a:tc>
                   <a:txBody>
                     <a:bodyPr/>
+                    <a:lstStyle/>
                     <a:p>
                       <a:pPr>
                         <a:buNone/>
@@ -12831,13 +12139,6 @@
                         </a:rPr>
                         <a:t>Figure 7. Auto-Trading Wizard – Step 3: Review &amp; Activate</a:t>
                       </a:r>
-                      <a:endParaRPr lang="en-US" altLang="en-US" sz="1200" b="1">
-                        <a:solidFill>
-                          <a:schemeClr val="bg1"/>
-                        </a:solidFill>
-                        <a:latin typeface="Times New Roman" panose="02020603050405020304" charset="0"/>
-                        <a:cs typeface="Times New Roman" panose="02020603050405020304" charset="0"/>
-                      </a:endParaRPr>
                     </a:p>
                   </a:txBody>
                   <a:tcPr>
@@ -12865,6 +12166,7 @@
                 <a:tc>
                   <a:txBody>
                     <a:bodyPr/>
+                    <a:lstStyle/>
                     <a:p>
                       <a:pPr>
                         <a:buNone/>
@@ -12951,13 +12253,6 @@
                         </a:rPr>
                         <a:t>Figure 8. AI Chatbot / Support Chat Screen </a:t>
                       </a:r>
-                      <a:endParaRPr lang="en-US" altLang="en-US" sz="1200" b="1">
-                        <a:solidFill>
-                          <a:schemeClr val="bg1"/>
-                        </a:solidFill>
-                        <a:latin typeface="Times New Roman" panose="02020603050405020304" charset="0"/>
-                        <a:cs typeface="Times New Roman" panose="02020603050405020304" charset="0"/>
-                      </a:endParaRPr>
                     </a:p>
                   </a:txBody>
                   <a:tcPr>
@@ -12982,6 +12277,11 @@
                     </a:gradFill>
                   </a:tcPr>
                 </a:tc>
+                <a:extLst>
+                  <a:ext uri="{0D108BD9-81ED-4DB2-BD59-A6C34878D82A}">
+                    <a16:rowId xmlns:a16="http://schemas.microsoft.com/office/drawing/2014/main" val="10001"/>
+                  </a:ext>
+                </a:extLst>
               </a:tr>
             </a:tbl>
           </a:graphicData>
@@ -12996,31 +12296,6 @@
           <p:nvPr/>
         </p:nvPicPr>
         <p:blipFill>
-          <a:blip r:embed="rId2"/>
-          <a:srcRect/>
-          <a:stretch>
-            <a:fillRect/>
-          </a:stretch>
-        </p:blipFill>
-        <p:spPr>
-          <a:xfrm>
-            <a:off x="913765" y="1388110"/>
-            <a:ext cx="2322830" cy="1971040"/>
-          </a:xfrm>
-          <a:prstGeom prst="rect">
-            <a:avLst/>
-          </a:prstGeom>
-        </p:spPr>
-      </p:pic>
-      <p:pic>
-        <p:nvPicPr>
-          <p:cNvPr id="8" name="Picture 2"/>
-          <p:cNvPicPr>
-            <a:picLocks noChangeAspect="1" noChangeArrowheads="1"/>
-          </p:cNvPicPr>
-          <p:nvPr/>
-        </p:nvPicPr>
-        <p:blipFill>
           <a:blip r:embed="rId3"/>
           <a:srcRect/>
           <a:stretch>
@@ -13029,8 +12304,8 @@
         </p:blipFill>
         <p:spPr>
           <a:xfrm>
-            <a:off x="3604895" y="1388110"/>
-            <a:ext cx="2500630" cy="2041525"/>
+            <a:off x="913765" y="1388110"/>
+            <a:ext cx="2322830" cy="1971040"/>
           </a:xfrm>
           <a:prstGeom prst="rect">
             <a:avLst/>
@@ -13039,7 +12314,7 @@
       </p:pic>
       <p:pic>
         <p:nvPicPr>
-          <p:cNvPr id="9" name="Picture 3"/>
+          <p:cNvPr id="8" name="Picture 2"/>
           <p:cNvPicPr>
             <a:picLocks noChangeAspect="1" noChangeArrowheads="1"/>
           </p:cNvPicPr>
@@ -13054,8 +12329,8 @@
         </p:blipFill>
         <p:spPr>
           <a:xfrm>
-            <a:off x="6298565" y="1388110"/>
-            <a:ext cx="2417445" cy="2041525"/>
+            <a:off x="3604895" y="1388110"/>
+            <a:ext cx="2500630" cy="2041525"/>
           </a:xfrm>
           <a:prstGeom prst="rect">
             <a:avLst/>
@@ -13064,7 +12339,7 @@
       </p:pic>
       <p:pic>
         <p:nvPicPr>
-          <p:cNvPr id="10" name="Picture 4"/>
+          <p:cNvPr id="9" name="Picture 3"/>
           <p:cNvPicPr>
             <a:picLocks noChangeAspect="1" noChangeArrowheads="1"/>
           </p:cNvPicPr>
@@ -13079,8 +12354,8 @@
         </p:blipFill>
         <p:spPr>
           <a:xfrm>
-            <a:off x="9017635" y="1388110"/>
-            <a:ext cx="2475230" cy="2148205"/>
+            <a:off x="6298565" y="1388110"/>
+            <a:ext cx="2417445" cy="2041525"/>
           </a:xfrm>
           <a:prstGeom prst="rect">
             <a:avLst/>
@@ -13089,7 +12364,7 @@
       </p:pic>
       <p:pic>
         <p:nvPicPr>
-          <p:cNvPr id="11" name="Picture 5"/>
+          <p:cNvPr id="10" name="Picture 4"/>
           <p:cNvPicPr>
             <a:picLocks noChangeAspect="1" noChangeArrowheads="1"/>
           </p:cNvPicPr>
@@ -13104,8 +12379,8 @@
         </p:blipFill>
         <p:spPr>
           <a:xfrm>
-            <a:off x="913765" y="4121150"/>
-            <a:ext cx="2477135" cy="2028825"/>
+            <a:off x="9017635" y="1388110"/>
+            <a:ext cx="2475230" cy="2148205"/>
           </a:xfrm>
           <a:prstGeom prst="rect">
             <a:avLst/>
@@ -13114,7 +12389,7 @@
       </p:pic>
       <p:pic>
         <p:nvPicPr>
-          <p:cNvPr id="12" name="Picture 6"/>
+          <p:cNvPr id="11" name="Picture 5"/>
           <p:cNvPicPr>
             <a:picLocks noChangeAspect="1" noChangeArrowheads="1"/>
           </p:cNvPicPr>
@@ -13129,8 +12404,8 @@
         </p:blipFill>
         <p:spPr>
           <a:xfrm>
-            <a:off x="3604895" y="4065905"/>
-            <a:ext cx="2420620" cy="2084070"/>
+            <a:off x="913765" y="4121150"/>
+            <a:ext cx="2477135" cy="2028825"/>
           </a:xfrm>
           <a:prstGeom prst="rect">
             <a:avLst/>
@@ -13139,7 +12414,7 @@
       </p:pic>
       <p:pic>
         <p:nvPicPr>
-          <p:cNvPr id="13" name="Picture 7"/>
+          <p:cNvPr id="12" name="Picture 6"/>
           <p:cNvPicPr>
             <a:picLocks noChangeAspect="1" noChangeArrowheads="1"/>
           </p:cNvPicPr>
@@ -13154,6 +12429,31 @@
         </p:blipFill>
         <p:spPr>
           <a:xfrm>
+            <a:off x="3604895" y="4065905"/>
+            <a:ext cx="2420620" cy="2084070"/>
+          </a:xfrm>
+          <a:prstGeom prst="rect">
+            <a:avLst/>
+          </a:prstGeom>
+        </p:spPr>
+      </p:pic>
+      <p:pic>
+        <p:nvPicPr>
+          <p:cNvPr id="13" name="Picture 7"/>
+          <p:cNvPicPr>
+            <a:picLocks noChangeAspect="1" noChangeArrowheads="1"/>
+          </p:cNvPicPr>
+          <p:nvPr/>
+        </p:nvPicPr>
+        <p:blipFill>
+          <a:blip r:embed="rId9"/>
+          <a:srcRect/>
+          <a:stretch>
+            <a:fillRect/>
+          </a:stretch>
+        </p:blipFill>
+        <p:spPr>
+          <a:xfrm>
             <a:off x="6239510" y="4065905"/>
             <a:ext cx="2475865" cy="2019935"/>
           </a:xfrm>
@@ -13171,7 +12471,7 @@
           <p:nvPr/>
         </p:nvPicPr>
         <p:blipFill>
-          <a:blip r:embed="rId9"/>
+          <a:blip r:embed="rId10"/>
           <a:srcRect/>
           <a:stretch>
             <a:fillRect/>
@@ -13248,6 +12548,7 @@
         </p:spPr>
         <p:txBody>
           <a:bodyPr/>
+          <a:lstStyle/>
           <a:p>
             <a:pPr marL="0" indent="0" algn="ctr">
               <a:buNone/>
@@ -13292,13 +12593,6 @@
               </a:rPr>
               <a:t>3-step guided workflow replacing the complex original setup</a:t>
             </a:r>
-            <a:endParaRPr lang="en-US" b="1" dirty="0">
-              <a:solidFill>
-                <a:srgbClr val="8FA3C0"/>
-              </a:solidFill>
-              <a:latin typeface="Times New Roman" panose="02020603050405020304" charset="0"/>
-              <a:cs typeface="Times New Roman" panose="02020603050405020304" charset="0"/>
-            </a:endParaRPr>
           </a:p>
         </p:txBody>
       </p:sp>
@@ -13398,13 +12692,6 @@
               </a:rPr>
               <a:t>Step 1</a:t>
             </a:r>
-            <a:endParaRPr lang="en-US" sz="1400" b="1" dirty="0">
-              <a:solidFill>
-                <a:srgbClr val="0A0E1A"/>
-              </a:solidFill>
-              <a:latin typeface="Times New Roman" panose="02020603050405020304" charset="0"/>
-              <a:cs typeface="Times New Roman" panose="02020603050405020304" charset="0"/>
-            </a:endParaRPr>
           </a:p>
         </p:txBody>
       </p:sp>
@@ -13445,13 +12732,6 @@
               </a:rPr>
               <a:t>Strategy Templates</a:t>
             </a:r>
-            <a:endParaRPr lang="en-US" sz="1400" b="1" dirty="0">
-              <a:solidFill>
-                <a:srgbClr val="FFFFFF"/>
-              </a:solidFill>
-              <a:latin typeface="Times New Roman" panose="02020603050405020304" charset="0"/>
-              <a:cs typeface="Times New Roman" panose="02020603050405020304" charset="0"/>
-            </a:endParaRPr>
           </a:p>
         </p:txBody>
       </p:sp>
@@ -13549,13 +12829,6 @@
               </a:rPr>
               <a:t>• Stop-Loss Protection</a:t>
             </a:r>
-            <a:endParaRPr lang="en-US" sz="1400" dirty="0">
-              <a:solidFill>
-                <a:srgbClr val="E8EDF5"/>
-              </a:solidFill>
-              <a:latin typeface="Times New Roman" panose="02020603050405020304" charset="0"/>
-              <a:cs typeface="Times New Roman" panose="02020603050405020304" charset="0"/>
-            </a:endParaRPr>
           </a:p>
           <a:p>
             <a:pPr marL="0" indent="0">
@@ -13702,13 +12975,6 @@
               </a:rPr>
               <a:t>Step 2</a:t>
             </a:r>
-            <a:endParaRPr lang="en-US" sz="1400" b="1" dirty="0">
-              <a:solidFill>
-                <a:srgbClr val="0A0E1A"/>
-              </a:solidFill>
-              <a:latin typeface="Times New Roman" panose="02020603050405020304" charset="0"/>
-              <a:cs typeface="Times New Roman" panose="02020603050405020304" charset="0"/>
-            </a:endParaRPr>
           </a:p>
         </p:txBody>
       </p:sp>
@@ -13749,13 +13015,6 @@
               </a:rPr>
               <a:t>Set Rules</a:t>
             </a:r>
-            <a:endParaRPr lang="en-US" sz="1400" b="1" dirty="0">
-              <a:solidFill>
-                <a:srgbClr val="FFFFFF"/>
-              </a:solidFill>
-              <a:latin typeface="Times New Roman" panose="02020603050405020304" charset="0"/>
-              <a:cs typeface="Times New Roman" panose="02020603050405020304" charset="0"/>
-            </a:endParaRPr>
           </a:p>
         </p:txBody>
       </p:sp>
@@ -13872,13 +13131,6 @@
               </a:rPr>
               <a:t>• Trading Interval</a:t>
             </a:r>
-            <a:endParaRPr lang="en-US" sz="1400" dirty="0">
-              <a:solidFill>
-                <a:srgbClr val="E8EDF5"/>
-              </a:solidFill>
-              <a:latin typeface="Times New Roman" panose="02020603050405020304" charset="0"/>
-              <a:cs typeface="Times New Roman" panose="02020603050405020304" charset="0"/>
-            </a:endParaRPr>
           </a:p>
           <a:p>
             <a:pPr marL="0" indent="0">
@@ -14015,13 +13267,6 @@
               </a:rPr>
               <a:t>Step 3</a:t>
             </a:r>
-            <a:endParaRPr lang="en-US" sz="1400" b="1" dirty="0">
-              <a:solidFill>
-                <a:srgbClr val="0A0E1A"/>
-              </a:solidFill>
-              <a:latin typeface="Times New Roman" panose="02020603050405020304" charset="0"/>
-              <a:cs typeface="Times New Roman" panose="02020603050405020304" charset="0"/>
-            </a:endParaRPr>
           </a:p>
         </p:txBody>
       </p:sp>
@@ -14062,13 +13307,6 @@
               </a:rPr>
               <a:t>Review &amp; Activate</a:t>
             </a:r>
-            <a:endParaRPr lang="en-US" sz="1400" b="1" dirty="0">
-              <a:solidFill>
-                <a:srgbClr val="FFFFFF"/>
-              </a:solidFill>
-              <a:latin typeface="Times New Roman" panose="02020603050405020304" charset="0"/>
-              <a:cs typeface="Times New Roman" panose="02020603050405020304" charset="0"/>
-            </a:endParaRPr>
           </a:p>
         </p:txBody>
       </p:sp>
@@ -14109,13 +13347,6 @@
               </a:rPr>
               <a:t>Full summary in clean 2-column card. 'Activate immediately' toggle defaults ON.</a:t>
             </a:r>
-            <a:endParaRPr lang="en-US" sz="1400" dirty="0">
-              <a:solidFill>
-                <a:srgbClr val="E8EDF5"/>
-              </a:solidFill>
-              <a:latin typeface="Times New Roman" panose="02020603050405020304" charset="0"/>
-              <a:cs typeface="Times New Roman" panose="02020603050405020304" charset="0"/>
-            </a:endParaRPr>
           </a:p>
           <a:p>
             <a:pPr marL="0" indent="0">
@@ -14208,13 +13439,6 @@
               </a:rPr>
               <a:t>Auto-Trading Wizard</a:t>
             </a:r>
-            <a:endParaRPr lang="en-US" sz="2800" b="1" dirty="0">
-              <a:solidFill>
-                <a:srgbClr val="FFFFFF"/>
-              </a:solidFill>
-              <a:latin typeface="Times New Roman" panose="02020603050405020304" charset="0"/>
-              <a:cs typeface="Times New Roman" panose="02020603050405020304" charset="0"/>
-            </a:endParaRPr>
           </a:p>
         </p:txBody>
       </p:sp>
@@ -14251,13 +13475,6 @@
               </a:rPr>
               <a:t>⚡  Projected improvement:  60% → 85% task completion   |   3 min 20 sec → 1 min 50 sec   |   ~45% time reduction</a:t>
             </a:r>
-            <a:endParaRPr lang="en-US" sz="1400" dirty="0">
-              <a:solidFill>
-                <a:srgbClr val="34A853"/>
-              </a:solidFill>
-              <a:latin typeface="Times New Roman" panose="02020603050405020304" charset="0"/>
-              <a:cs typeface="Times New Roman" panose="02020603050405020304" charset="0"/>
-            </a:endParaRPr>
           </a:p>
         </p:txBody>
       </p:sp>
@@ -14322,6 +13539,7 @@
         </p:spPr>
         <p:txBody>
           <a:bodyPr/>
+          <a:lstStyle/>
           <a:p>
             <a:pPr marL="0" indent="0" algn="ctr">
               <a:buNone/>
@@ -14353,6 +13571,7 @@
           <a:bodyPr wrap="square" rtlCol="0" anchor="t">
             <a:spAutoFit/>
           </a:bodyPr>
+          <a:lstStyle/>
           <a:p>
             <a:pPr marL="0" indent="0">
               <a:buNone/>
@@ -14368,14 +13587,6 @@
               </a:rPr>
               <a:t>Heuristic Evaluation</a:t>
             </a:r>
-            <a:endParaRPr lang="en-US" sz="2800" b="1" dirty="0">
-              <a:solidFill>
-                <a:srgbClr val="FFFFFF"/>
-              </a:solidFill>
-              <a:latin typeface="Times New Roman" panose="02020603050405020304" charset="0"/>
-              <a:cs typeface="Times New Roman" panose="02020603050405020304" charset="0"/>
-              <a:sym typeface="+mn-ea"/>
-            </a:endParaRPr>
           </a:p>
         </p:txBody>
       </p:sp>
@@ -14412,13 +13623,6 @@
               </a:rPr>
               <a:t>All 10 Nielsen heuristics evaluated — all resolved in redesign</a:t>
             </a:r>
-            <a:endParaRPr lang="en-US" b="1" dirty="0">
-              <a:solidFill>
-                <a:srgbClr val="8FA3C0"/>
-              </a:solidFill>
-              <a:latin typeface="Times New Roman" panose="02020603050405020304" charset="0"/>
-              <a:cs typeface="Times New Roman" panose="02020603050405020304" charset="0"/>
-            </a:endParaRPr>
           </a:p>
         </p:txBody>
       </p:sp>
@@ -14431,7 +13635,7 @@
           <p:nvPr/>
         </p:nvPicPr>
         <p:blipFill>
-          <a:blip r:embed="rId1"/>
+          <a:blip r:embed="rId2"/>
           <a:stretch>
             <a:fillRect/>
           </a:stretch>
@@ -14455,256 +13659,256 @@
 </file>
 
 <file path=ppt/tags/tag1.xml><?xml version="1.0" encoding="utf-8"?>
-<p:tagLst xmlns:p="http://schemas.openxmlformats.org/presentationml/2006/main">
+<p:tagLst xmlns:a="http://schemas.openxmlformats.org/drawingml/2006/main" xmlns:r="http://schemas.openxmlformats.org/officeDocument/2006/relationships" xmlns:p="http://schemas.openxmlformats.org/presentationml/2006/main">
   <p:tag name="TABLE_ENDDRAG_ORIGIN_RECT" val="494*108"/>
   <p:tag name="TABLE_ENDDRAG_RECT" val="111*392*494*108"/>
 </p:tagLst>
 </file>
 
 <file path=ppt/tags/tag10.xml><?xml version="1.0" encoding="utf-8"?>
-<p:tagLst xmlns:p="http://schemas.openxmlformats.org/presentationml/2006/main">
+<p:tagLst xmlns:a="http://schemas.openxmlformats.org/drawingml/2006/main" xmlns:r="http://schemas.openxmlformats.org/officeDocument/2006/relationships" xmlns:p="http://schemas.openxmlformats.org/presentationml/2006/main">
   <p:tag name="KSO_WM_DIAGRAM_VIRTUALLY_FRAME" val="{&quot;height&quot;:302.4,&quot;left&quot;:28.8,&quot;top&quot;:79.2,&quot;width&quot;:684}"/>
 </p:tagLst>
 </file>
 
 <file path=ppt/tags/tag11.xml><?xml version="1.0" encoding="utf-8"?>
-<p:tagLst xmlns:p="http://schemas.openxmlformats.org/presentationml/2006/main">
+<p:tagLst xmlns:a="http://schemas.openxmlformats.org/drawingml/2006/main" xmlns:r="http://schemas.openxmlformats.org/officeDocument/2006/relationships" xmlns:p="http://schemas.openxmlformats.org/presentationml/2006/main">
   <p:tag name="KSO_WM_DIAGRAM_VIRTUALLY_FRAME" val="{&quot;height&quot;:302.4,&quot;left&quot;:28.8,&quot;top&quot;:79.2,&quot;width&quot;:684}"/>
 </p:tagLst>
 </file>
 
 <file path=ppt/tags/tag12.xml><?xml version="1.0" encoding="utf-8"?>
-<p:tagLst xmlns:p="http://schemas.openxmlformats.org/presentationml/2006/main">
+<p:tagLst xmlns:a="http://schemas.openxmlformats.org/drawingml/2006/main" xmlns:r="http://schemas.openxmlformats.org/officeDocument/2006/relationships" xmlns:p="http://schemas.openxmlformats.org/presentationml/2006/main">
   <p:tag name="KSO_WM_DIAGRAM_VIRTUALLY_FRAME" val="{&quot;height&quot;:302.4,&quot;left&quot;:28.8,&quot;top&quot;:79.2,&quot;width&quot;:684}"/>
 </p:tagLst>
 </file>
 
 <file path=ppt/tags/tag13.xml><?xml version="1.0" encoding="utf-8"?>
-<p:tagLst xmlns:p="http://schemas.openxmlformats.org/presentationml/2006/main">
+<p:tagLst xmlns:a="http://schemas.openxmlformats.org/drawingml/2006/main" xmlns:r="http://schemas.openxmlformats.org/officeDocument/2006/relationships" xmlns:p="http://schemas.openxmlformats.org/presentationml/2006/main">
   <p:tag name="KSO_WM_DIAGRAM_VIRTUALLY_FRAME" val="{&quot;height&quot;:302.4,&quot;left&quot;:28.8,&quot;top&quot;:79.2,&quot;width&quot;:684}"/>
 </p:tagLst>
 </file>
 
 <file path=ppt/tags/tag14.xml><?xml version="1.0" encoding="utf-8"?>
-<p:tagLst xmlns:p="http://schemas.openxmlformats.org/presentationml/2006/main">
+<p:tagLst xmlns:a="http://schemas.openxmlformats.org/drawingml/2006/main" xmlns:r="http://schemas.openxmlformats.org/officeDocument/2006/relationships" xmlns:p="http://schemas.openxmlformats.org/presentationml/2006/main">
   <p:tag name="KSO_WM_DIAGRAM_VIRTUALLY_FRAME" val="{&quot;height&quot;:302.4,&quot;left&quot;:28.8,&quot;top&quot;:79.2,&quot;width&quot;:684}"/>
 </p:tagLst>
 </file>
 
 <file path=ppt/tags/tag15.xml><?xml version="1.0" encoding="utf-8"?>
-<p:tagLst xmlns:p="http://schemas.openxmlformats.org/presentationml/2006/main">
+<p:tagLst xmlns:a="http://schemas.openxmlformats.org/drawingml/2006/main" xmlns:r="http://schemas.openxmlformats.org/officeDocument/2006/relationships" xmlns:p="http://schemas.openxmlformats.org/presentationml/2006/main">
   <p:tag name="KSO_WM_DIAGRAM_VIRTUALLY_FRAME" val="{&quot;height&quot;:302.4,&quot;left&quot;:28.8,&quot;top&quot;:79.2,&quot;width&quot;:684}"/>
 </p:tagLst>
 </file>
 
 <file path=ppt/tags/tag16.xml><?xml version="1.0" encoding="utf-8"?>
-<p:tagLst xmlns:p="http://schemas.openxmlformats.org/presentationml/2006/main">
+<p:tagLst xmlns:a="http://schemas.openxmlformats.org/drawingml/2006/main" xmlns:r="http://schemas.openxmlformats.org/officeDocument/2006/relationships" xmlns:p="http://schemas.openxmlformats.org/presentationml/2006/main">
   <p:tag name="KSO_WM_DIAGRAM_VIRTUALLY_FRAME" val="{&quot;height&quot;:302.4,&quot;left&quot;:28.8,&quot;top&quot;:79.2,&quot;width&quot;:684}"/>
 </p:tagLst>
 </file>
 
 <file path=ppt/tags/tag17.xml><?xml version="1.0" encoding="utf-8"?>
-<p:tagLst xmlns:p="http://schemas.openxmlformats.org/presentationml/2006/main">
+<p:tagLst xmlns:a="http://schemas.openxmlformats.org/drawingml/2006/main" xmlns:r="http://schemas.openxmlformats.org/officeDocument/2006/relationships" xmlns:p="http://schemas.openxmlformats.org/presentationml/2006/main">
   <p:tag name="KSO_WM_DIAGRAM_VIRTUALLY_FRAME" val="{&quot;height&quot;:302.4,&quot;left&quot;:28.8,&quot;top&quot;:79.2,&quot;width&quot;:684}"/>
 </p:tagLst>
 </file>
 
 <file path=ppt/tags/tag18.xml><?xml version="1.0" encoding="utf-8"?>
-<p:tagLst xmlns:p="http://schemas.openxmlformats.org/presentationml/2006/main">
+<p:tagLst xmlns:a="http://schemas.openxmlformats.org/drawingml/2006/main" xmlns:r="http://schemas.openxmlformats.org/officeDocument/2006/relationships" xmlns:p="http://schemas.openxmlformats.org/presentationml/2006/main">
   <p:tag name="KSO_WM_DIAGRAM_VIRTUALLY_FRAME" val="{&quot;height&quot;:302.4,&quot;left&quot;:28.8,&quot;top&quot;:79.2,&quot;width&quot;:684}"/>
 </p:tagLst>
 </file>
 
 <file path=ppt/tags/tag19.xml><?xml version="1.0" encoding="utf-8"?>
-<p:tagLst xmlns:p="http://schemas.openxmlformats.org/presentationml/2006/main">
+<p:tagLst xmlns:a="http://schemas.openxmlformats.org/drawingml/2006/main" xmlns:r="http://schemas.openxmlformats.org/officeDocument/2006/relationships" xmlns:p="http://schemas.openxmlformats.org/presentationml/2006/main">
   <p:tag name="KSO_WM_DIAGRAM_VIRTUALLY_FRAME" val="{&quot;height&quot;:302.4,&quot;left&quot;:28.8,&quot;top&quot;:79.2,&quot;width&quot;:684}"/>
 </p:tagLst>
 </file>
 
 <file path=ppt/tags/tag2.xml><?xml version="1.0" encoding="utf-8"?>
-<p:tagLst xmlns:p="http://schemas.openxmlformats.org/presentationml/2006/main">
+<p:tagLst xmlns:a="http://schemas.openxmlformats.org/drawingml/2006/main" xmlns:r="http://schemas.openxmlformats.org/officeDocument/2006/relationships" xmlns:p="http://schemas.openxmlformats.org/presentationml/2006/main">
   <p:tag name="KSO_WM_DIAGRAM_VIRTUALLY_FRAME" val="{&quot;height&quot;:302.4,&quot;left&quot;:28.8,&quot;top&quot;:79.2,&quot;width&quot;:684}"/>
 </p:tagLst>
 </file>
 
 <file path=ppt/tags/tag20.xml><?xml version="1.0" encoding="utf-8"?>
-<p:tagLst xmlns:p="http://schemas.openxmlformats.org/presentationml/2006/main">
+<p:tagLst xmlns:a="http://schemas.openxmlformats.org/drawingml/2006/main" xmlns:r="http://schemas.openxmlformats.org/officeDocument/2006/relationships" xmlns:p="http://schemas.openxmlformats.org/presentationml/2006/main">
   <p:tag name="KSO_WM_DIAGRAM_VIRTUALLY_FRAME" val="{&quot;height&quot;:302.4,&quot;left&quot;:28.8,&quot;top&quot;:79.2,&quot;width&quot;:684}"/>
 </p:tagLst>
 </file>
 
 <file path=ppt/tags/tag21.xml><?xml version="1.0" encoding="utf-8"?>
-<p:tagLst xmlns:p="http://schemas.openxmlformats.org/presentationml/2006/main">
+<p:tagLst xmlns:a="http://schemas.openxmlformats.org/drawingml/2006/main" xmlns:r="http://schemas.openxmlformats.org/officeDocument/2006/relationships" xmlns:p="http://schemas.openxmlformats.org/presentationml/2006/main">
   <p:tag name="KSO_WM_DIAGRAM_VIRTUALLY_FRAME" val="{&quot;height&quot;:302.4,&quot;left&quot;:28.8,&quot;top&quot;:79.2,&quot;width&quot;:684}"/>
 </p:tagLst>
 </file>
 
 <file path=ppt/tags/tag22.xml><?xml version="1.0" encoding="utf-8"?>
-<p:tagLst xmlns:p="http://schemas.openxmlformats.org/presentationml/2006/main">
+<p:tagLst xmlns:a="http://schemas.openxmlformats.org/drawingml/2006/main" xmlns:r="http://schemas.openxmlformats.org/officeDocument/2006/relationships" xmlns:p="http://schemas.openxmlformats.org/presentationml/2006/main">
   <p:tag name="KSO_WM_DIAGRAM_VIRTUALLY_FRAME" val="{&quot;height&quot;:302.4,&quot;left&quot;:28.8,&quot;top&quot;:79.2,&quot;width&quot;:684}"/>
 </p:tagLst>
 </file>
 
 <file path=ppt/tags/tag23.xml><?xml version="1.0" encoding="utf-8"?>
-<p:tagLst xmlns:p="http://schemas.openxmlformats.org/presentationml/2006/main">
+<p:tagLst xmlns:a="http://schemas.openxmlformats.org/drawingml/2006/main" xmlns:r="http://schemas.openxmlformats.org/officeDocument/2006/relationships" xmlns:p="http://schemas.openxmlformats.org/presentationml/2006/main">
   <p:tag name="KSO_WM_DIAGRAM_VIRTUALLY_FRAME" val="{&quot;height&quot;:302.4,&quot;left&quot;:28.8,&quot;top&quot;:79.2,&quot;width&quot;:684}"/>
 </p:tagLst>
 </file>
 
 <file path=ppt/tags/tag24.xml><?xml version="1.0" encoding="utf-8"?>
-<p:tagLst xmlns:p="http://schemas.openxmlformats.org/presentationml/2006/main">
+<p:tagLst xmlns:a="http://schemas.openxmlformats.org/drawingml/2006/main" xmlns:r="http://schemas.openxmlformats.org/officeDocument/2006/relationships" xmlns:p="http://schemas.openxmlformats.org/presentationml/2006/main">
   <p:tag name="KSO_WM_DIAGRAM_VIRTUALLY_FRAME" val="{&quot;height&quot;:302.4,&quot;left&quot;:28.8,&quot;top&quot;:79.2,&quot;width&quot;:684}"/>
 </p:tagLst>
 </file>
 
 <file path=ppt/tags/tag25.xml><?xml version="1.0" encoding="utf-8"?>
-<p:tagLst xmlns:p="http://schemas.openxmlformats.org/presentationml/2006/main">
+<p:tagLst xmlns:a="http://schemas.openxmlformats.org/drawingml/2006/main" xmlns:r="http://schemas.openxmlformats.org/officeDocument/2006/relationships" xmlns:p="http://schemas.openxmlformats.org/presentationml/2006/main">
   <p:tag name="KSO_WM_DIAGRAM_VIRTUALLY_FRAME" val="{&quot;height&quot;:302.4,&quot;left&quot;:28.8,&quot;top&quot;:79.2,&quot;width&quot;:684}"/>
 </p:tagLst>
 </file>
 
 <file path=ppt/tags/tag26.xml><?xml version="1.0" encoding="utf-8"?>
-<p:tagLst xmlns:p="http://schemas.openxmlformats.org/presentationml/2006/main">
+<p:tagLst xmlns:a="http://schemas.openxmlformats.org/drawingml/2006/main" xmlns:r="http://schemas.openxmlformats.org/officeDocument/2006/relationships" xmlns:p="http://schemas.openxmlformats.org/presentationml/2006/main">
   <p:tag name="TABLE_ENDDRAG_ORIGIN_RECT" val="845*424"/>
   <p:tag name="TABLE_ENDDRAG_RECT" val="62*102*845*424"/>
 </p:tagLst>
 </file>
 
 <file path=ppt/tags/tag27.xml><?xml version="1.0" encoding="utf-8"?>
-<p:tagLst xmlns:p="http://schemas.openxmlformats.org/presentationml/2006/main">
+<p:tagLst xmlns:a="http://schemas.openxmlformats.org/drawingml/2006/main" xmlns:r="http://schemas.openxmlformats.org/officeDocument/2006/relationships" xmlns:p="http://schemas.openxmlformats.org/presentationml/2006/main">
   <p:tag name="KSO_WM_DIAGRAM_VIRTUALLY_FRAME" val="{&quot;height&quot;:283.85,&quot;left&quot;:28.8,&quot;top&quot;:79.2,&quot;width&quot;:666.95}"/>
 </p:tagLst>
 </file>
 
 <file path=ppt/tags/tag28.xml><?xml version="1.0" encoding="utf-8"?>
-<p:tagLst xmlns:p="http://schemas.openxmlformats.org/presentationml/2006/main">
+<p:tagLst xmlns:a="http://schemas.openxmlformats.org/drawingml/2006/main" xmlns:r="http://schemas.openxmlformats.org/officeDocument/2006/relationships" xmlns:p="http://schemas.openxmlformats.org/presentationml/2006/main">
   <p:tag name="KSO_WM_DIAGRAM_VIRTUALLY_FRAME" val="{&quot;height&quot;:283.85,&quot;left&quot;:28.8,&quot;top&quot;:79.2,&quot;width&quot;:666.95}"/>
 </p:tagLst>
 </file>
 
 <file path=ppt/tags/tag29.xml><?xml version="1.0" encoding="utf-8"?>
-<p:tagLst xmlns:p="http://schemas.openxmlformats.org/presentationml/2006/main">
+<p:tagLst xmlns:a="http://schemas.openxmlformats.org/drawingml/2006/main" xmlns:r="http://schemas.openxmlformats.org/officeDocument/2006/relationships" xmlns:p="http://schemas.openxmlformats.org/presentationml/2006/main">
   <p:tag name="KSO_WM_DIAGRAM_VIRTUALLY_FRAME" val="{&quot;height&quot;:283.85,&quot;left&quot;:28.8,&quot;top&quot;:79.2,&quot;width&quot;:666.95}"/>
 </p:tagLst>
 </file>
 
 <file path=ppt/tags/tag3.xml><?xml version="1.0" encoding="utf-8"?>
-<p:tagLst xmlns:p="http://schemas.openxmlformats.org/presentationml/2006/main">
+<p:tagLst xmlns:a="http://schemas.openxmlformats.org/drawingml/2006/main" xmlns:r="http://schemas.openxmlformats.org/officeDocument/2006/relationships" xmlns:p="http://schemas.openxmlformats.org/presentationml/2006/main">
   <p:tag name="KSO_WM_DIAGRAM_VIRTUALLY_FRAME" val="{&quot;height&quot;:302.4,&quot;left&quot;:28.8,&quot;top&quot;:79.2,&quot;width&quot;:684}"/>
 </p:tagLst>
 </file>
 
 <file path=ppt/tags/tag30.xml><?xml version="1.0" encoding="utf-8"?>
-<p:tagLst xmlns:p="http://schemas.openxmlformats.org/presentationml/2006/main">
+<p:tagLst xmlns:a="http://schemas.openxmlformats.org/drawingml/2006/main" xmlns:r="http://schemas.openxmlformats.org/officeDocument/2006/relationships" xmlns:p="http://schemas.openxmlformats.org/presentationml/2006/main">
   <p:tag name="KSO_WM_DIAGRAM_VIRTUALLY_FRAME" val="{&quot;height&quot;:283.85,&quot;left&quot;:28.8,&quot;top&quot;:79.2,&quot;width&quot;:666.95}"/>
 </p:tagLst>
 </file>
 
 <file path=ppt/tags/tag31.xml><?xml version="1.0" encoding="utf-8"?>
-<p:tagLst xmlns:p="http://schemas.openxmlformats.org/presentationml/2006/main">
+<p:tagLst xmlns:a="http://schemas.openxmlformats.org/drawingml/2006/main" xmlns:r="http://schemas.openxmlformats.org/officeDocument/2006/relationships" xmlns:p="http://schemas.openxmlformats.org/presentationml/2006/main">
   <p:tag name="KSO_WM_DIAGRAM_VIRTUALLY_FRAME" val="{&quot;height&quot;:283.85,&quot;left&quot;:28.8,&quot;top&quot;:79.2,&quot;width&quot;:666.95}"/>
 </p:tagLst>
 </file>
 
 <file path=ppt/tags/tag32.xml><?xml version="1.0" encoding="utf-8"?>
-<p:tagLst xmlns:p="http://schemas.openxmlformats.org/presentationml/2006/main">
+<p:tagLst xmlns:a="http://schemas.openxmlformats.org/drawingml/2006/main" xmlns:r="http://schemas.openxmlformats.org/officeDocument/2006/relationships" xmlns:p="http://schemas.openxmlformats.org/presentationml/2006/main">
   <p:tag name="KSO_WM_DIAGRAM_VIRTUALLY_FRAME" val="{&quot;height&quot;:283.85,&quot;left&quot;:28.8,&quot;top&quot;:79.2,&quot;width&quot;:666.95}"/>
 </p:tagLst>
 </file>
 
 <file path=ppt/tags/tag33.xml><?xml version="1.0" encoding="utf-8"?>
-<p:tagLst xmlns:p="http://schemas.openxmlformats.org/presentationml/2006/main">
+<p:tagLst xmlns:a="http://schemas.openxmlformats.org/drawingml/2006/main" xmlns:r="http://schemas.openxmlformats.org/officeDocument/2006/relationships" xmlns:p="http://schemas.openxmlformats.org/presentationml/2006/main">
   <p:tag name="KSO_WM_DIAGRAM_VIRTUALLY_FRAME" val="{&quot;height&quot;:283.85,&quot;left&quot;:28.8,&quot;top&quot;:79.2,&quot;width&quot;:666.95}"/>
 </p:tagLst>
 </file>
 
 <file path=ppt/tags/tag34.xml><?xml version="1.0" encoding="utf-8"?>
-<p:tagLst xmlns:p="http://schemas.openxmlformats.org/presentationml/2006/main">
+<p:tagLst xmlns:a="http://schemas.openxmlformats.org/drawingml/2006/main" xmlns:r="http://schemas.openxmlformats.org/officeDocument/2006/relationships" xmlns:p="http://schemas.openxmlformats.org/presentationml/2006/main">
   <p:tag name="KSO_WM_DIAGRAM_VIRTUALLY_FRAME" val="{&quot;height&quot;:283.85,&quot;left&quot;:28.8,&quot;top&quot;:79.2,&quot;width&quot;:666.95}"/>
 </p:tagLst>
 </file>
 
 <file path=ppt/tags/tag35.xml><?xml version="1.0" encoding="utf-8"?>
-<p:tagLst xmlns:p="http://schemas.openxmlformats.org/presentationml/2006/main">
+<p:tagLst xmlns:a="http://schemas.openxmlformats.org/drawingml/2006/main" xmlns:r="http://schemas.openxmlformats.org/officeDocument/2006/relationships" xmlns:p="http://schemas.openxmlformats.org/presentationml/2006/main">
   <p:tag name="KSO_WM_DIAGRAM_VIRTUALLY_FRAME" val="{&quot;height&quot;:283.85,&quot;left&quot;:28.8,&quot;top&quot;:79.2,&quot;width&quot;:666.95}"/>
 </p:tagLst>
 </file>
 
 <file path=ppt/tags/tag36.xml><?xml version="1.0" encoding="utf-8"?>
-<p:tagLst xmlns:p="http://schemas.openxmlformats.org/presentationml/2006/main">
+<p:tagLst xmlns:a="http://schemas.openxmlformats.org/drawingml/2006/main" xmlns:r="http://schemas.openxmlformats.org/officeDocument/2006/relationships" xmlns:p="http://schemas.openxmlformats.org/presentationml/2006/main">
   <p:tag name="KSO_WM_DIAGRAM_VIRTUALLY_FRAME" val="{&quot;height&quot;:283.85,&quot;left&quot;:28.8,&quot;top&quot;:79.2,&quot;width&quot;:666.95}"/>
 </p:tagLst>
 </file>
 
 <file path=ppt/tags/tag37.xml><?xml version="1.0" encoding="utf-8"?>
-<p:tagLst xmlns:p="http://schemas.openxmlformats.org/presentationml/2006/main">
+<p:tagLst xmlns:a="http://schemas.openxmlformats.org/drawingml/2006/main" xmlns:r="http://schemas.openxmlformats.org/officeDocument/2006/relationships" xmlns:p="http://schemas.openxmlformats.org/presentationml/2006/main">
   <p:tag name="KSO_WM_DIAGRAM_VIRTUALLY_FRAME" val="{&quot;height&quot;:283.85,&quot;left&quot;:28.8,&quot;top&quot;:79.2,&quot;width&quot;:666.95}"/>
 </p:tagLst>
 </file>
 
 <file path=ppt/tags/tag38.xml><?xml version="1.0" encoding="utf-8"?>
-<p:tagLst xmlns:p="http://schemas.openxmlformats.org/presentationml/2006/main">
+<p:tagLst xmlns:a="http://schemas.openxmlformats.org/drawingml/2006/main" xmlns:r="http://schemas.openxmlformats.org/officeDocument/2006/relationships" xmlns:p="http://schemas.openxmlformats.org/presentationml/2006/main">
   <p:tag name="KSO_WM_DIAGRAM_VIRTUALLY_FRAME" val="{&quot;height&quot;:283.85,&quot;left&quot;:28.8,&quot;top&quot;:79.2,&quot;width&quot;:666.95}"/>
 </p:tagLst>
 </file>
 
 <file path=ppt/tags/tag39.xml><?xml version="1.0" encoding="utf-8"?>
-<p:tagLst xmlns:p="http://schemas.openxmlformats.org/presentationml/2006/main">
+<p:tagLst xmlns:a="http://schemas.openxmlformats.org/drawingml/2006/main" xmlns:r="http://schemas.openxmlformats.org/officeDocument/2006/relationships" xmlns:p="http://schemas.openxmlformats.org/presentationml/2006/main">
   <p:tag name="KSO_WM_DIAGRAM_VIRTUALLY_FRAME" val="{&quot;height&quot;:283.85,&quot;left&quot;:28.8,&quot;top&quot;:79.2,&quot;width&quot;:666.95}"/>
 </p:tagLst>
 </file>
 
 <file path=ppt/tags/tag4.xml><?xml version="1.0" encoding="utf-8"?>
-<p:tagLst xmlns:p="http://schemas.openxmlformats.org/presentationml/2006/main">
+<p:tagLst xmlns:a="http://schemas.openxmlformats.org/drawingml/2006/main" xmlns:r="http://schemas.openxmlformats.org/officeDocument/2006/relationships" xmlns:p="http://schemas.openxmlformats.org/presentationml/2006/main">
   <p:tag name="KSO_WM_DIAGRAM_VIRTUALLY_FRAME" val="{&quot;height&quot;:302.4,&quot;left&quot;:28.8,&quot;top&quot;:79.2,&quot;width&quot;:684}"/>
 </p:tagLst>
 </file>
 
 <file path=ppt/tags/tag40.xml><?xml version="1.0" encoding="utf-8"?>
-<p:tagLst xmlns:p="http://schemas.openxmlformats.org/presentationml/2006/main">
+<p:tagLst xmlns:a="http://schemas.openxmlformats.org/drawingml/2006/main" xmlns:r="http://schemas.openxmlformats.org/officeDocument/2006/relationships" xmlns:p="http://schemas.openxmlformats.org/presentationml/2006/main">
   <p:tag name="KSO_WM_DIAGRAM_VIRTUALLY_FRAME" val="{&quot;height&quot;:283.85,&quot;left&quot;:28.8,&quot;top&quot;:79.2,&quot;width&quot;:666.95}"/>
 </p:tagLst>
 </file>
 
 <file path=ppt/tags/tag41.xml><?xml version="1.0" encoding="utf-8"?>
-<p:tagLst xmlns:p="http://schemas.openxmlformats.org/presentationml/2006/main">
+<p:tagLst xmlns:a="http://schemas.openxmlformats.org/drawingml/2006/main" xmlns:r="http://schemas.openxmlformats.org/officeDocument/2006/relationships" xmlns:p="http://schemas.openxmlformats.org/presentationml/2006/main">
   <p:tag name="KSO_WM_DIAGRAM_VIRTUALLY_FRAME" val="{&quot;height&quot;:283.85,&quot;left&quot;:28.8,&quot;top&quot;:79.2,&quot;width&quot;:666.95}"/>
 </p:tagLst>
 </file>
 
 <file path=ppt/tags/tag42.xml><?xml version="1.0" encoding="utf-8"?>
-<p:tagLst xmlns:p="http://schemas.openxmlformats.org/presentationml/2006/main">
+<p:tagLst xmlns:a="http://schemas.openxmlformats.org/drawingml/2006/main" xmlns:r="http://schemas.openxmlformats.org/officeDocument/2006/relationships" xmlns:p="http://schemas.openxmlformats.org/presentationml/2006/main">
   <p:tag name="TABLE_ENDDRAG_ORIGIN_RECT" val="668*317"/>
   <p:tag name="TABLE_ENDDRAG_RECT" val="109*128*668*317"/>
 </p:tagLst>
 </file>
 
 <file path=ppt/tags/tag5.xml><?xml version="1.0" encoding="utf-8"?>
-<p:tagLst xmlns:p="http://schemas.openxmlformats.org/presentationml/2006/main">
+<p:tagLst xmlns:a="http://schemas.openxmlformats.org/drawingml/2006/main" xmlns:r="http://schemas.openxmlformats.org/officeDocument/2006/relationships" xmlns:p="http://schemas.openxmlformats.org/presentationml/2006/main">
   <p:tag name="KSO_WM_DIAGRAM_VIRTUALLY_FRAME" val="{&quot;height&quot;:302.4,&quot;left&quot;:28.8,&quot;top&quot;:79.2,&quot;width&quot;:684}"/>
 </p:tagLst>
 </file>
 
 <file path=ppt/tags/tag6.xml><?xml version="1.0" encoding="utf-8"?>
-<p:tagLst xmlns:p="http://schemas.openxmlformats.org/presentationml/2006/main">
+<p:tagLst xmlns:a="http://schemas.openxmlformats.org/drawingml/2006/main" xmlns:r="http://schemas.openxmlformats.org/officeDocument/2006/relationships" xmlns:p="http://schemas.openxmlformats.org/presentationml/2006/main">
   <p:tag name="KSO_WM_DIAGRAM_VIRTUALLY_FRAME" val="{&quot;height&quot;:302.4,&quot;left&quot;:28.8,&quot;top&quot;:79.2,&quot;width&quot;:684}"/>
 </p:tagLst>
 </file>
 
 <file path=ppt/tags/tag7.xml><?xml version="1.0" encoding="utf-8"?>
-<p:tagLst xmlns:p="http://schemas.openxmlformats.org/presentationml/2006/main">
+<p:tagLst xmlns:a="http://schemas.openxmlformats.org/drawingml/2006/main" xmlns:r="http://schemas.openxmlformats.org/officeDocument/2006/relationships" xmlns:p="http://schemas.openxmlformats.org/presentationml/2006/main">
   <p:tag name="KSO_WM_DIAGRAM_VIRTUALLY_FRAME" val="{&quot;height&quot;:302.4,&quot;left&quot;:28.8,&quot;top&quot;:79.2,&quot;width&quot;:684}"/>
 </p:tagLst>
 </file>
 
 <file path=ppt/tags/tag8.xml><?xml version="1.0" encoding="utf-8"?>
-<p:tagLst xmlns:p="http://schemas.openxmlformats.org/presentationml/2006/main">
+<p:tagLst xmlns:a="http://schemas.openxmlformats.org/drawingml/2006/main" xmlns:r="http://schemas.openxmlformats.org/officeDocument/2006/relationships" xmlns:p="http://schemas.openxmlformats.org/presentationml/2006/main">
   <p:tag name="KSO_WM_DIAGRAM_VIRTUALLY_FRAME" val="{&quot;height&quot;:302.4,&quot;left&quot;:28.8,&quot;top&quot;:79.2,&quot;width&quot;:684}"/>
 </p:tagLst>
 </file>
 
 <file path=ppt/tags/tag9.xml><?xml version="1.0" encoding="utf-8"?>
-<p:tagLst xmlns:p="http://schemas.openxmlformats.org/presentationml/2006/main">
+<p:tagLst xmlns:a="http://schemas.openxmlformats.org/drawingml/2006/main" xmlns:r="http://schemas.openxmlformats.org/officeDocument/2006/relationships" xmlns:p="http://schemas.openxmlformats.org/presentationml/2006/main">
   <p:tag name="KSO_WM_DIAGRAM_VIRTUALLY_FRAME" val="{&quot;height&quot;:302.4,&quot;left&quot;:28.8,&quot;top&quot;:79.2,&quot;width&quot;:684}"/>
 </p:tagLst>
 </file>
@@ -14960,6 +14164,8 @@
       </a:bgFillStyleLst>
     </a:fmtScheme>
   </a:themeElements>
+  <a:objectDefaults/>
+  <a:extraClrSchemeLst/>
   <a:extLst>
     <a:ext uri="{05A4C25C-085E-4340-85A3-A5531E510DB2}">
       <thm15:themeFamily xmlns:thm15="http://schemas.microsoft.com/office/thememl/2012/main" name="Office Theme" id="{62F939B6-93AF-4DB8-9C6B-D6C7DFDC589F}" vid="{4A3C46E8-61CC-4603-A589-7422A47A8E4A}"/>

</xml_diff>